<commit_message>
Update UI and presentation outputs
</commit_message>
<xml_diff>
--- a/outputs/Apexformz_startup_pitch.pptx
+++ b/outputs/Apexformz_startup_pitch.pptx
@@ -2,23 +2,23 @@
 <file path=ppt/presentation.xml><?xml version="1.0" encoding="utf-8"?>
 <p:presentation xmlns:p="http://schemas.openxmlformats.org/presentationml/2006/main">
   <p:sldMasterIdLst>
-    <p:sldMasterId xmlns:r="http://schemas.openxmlformats.org/officeDocument/2006/relationships" id="2147483648" r:id="R7fc6e6ec5f534e1b"/>
+    <p:sldMasterId xmlns:r="http://schemas.openxmlformats.org/officeDocument/2006/relationships" id="2147483648" r:id="R1d46e2ac0e7140b1"/>
   </p:sldMasterIdLst>
   <p:notesMasterIdLst>
-    <p:notesMasterId xmlns:r="http://schemas.openxmlformats.org/officeDocument/2006/relationships" r:id="R6e83d2eb3e774b5e"/>
+    <p:notesMasterId xmlns:r="http://schemas.openxmlformats.org/officeDocument/2006/relationships" r:id="Rb968d1889a3e413b"/>
   </p:notesMasterIdLst>
   <p:sldIdLst>
-    <p:sldId xmlns:r="http://schemas.openxmlformats.org/officeDocument/2006/relationships" id="256" r:id="Rd62e65adee8040d6"/>
-    <p:sldId xmlns:r="http://schemas.openxmlformats.org/officeDocument/2006/relationships" id="257" r:id="R311a5ef19b0543cc"/>
-    <p:sldId xmlns:r="http://schemas.openxmlformats.org/officeDocument/2006/relationships" id="258" r:id="Rd73d8fefb7df4fff"/>
-    <p:sldId xmlns:r="http://schemas.openxmlformats.org/officeDocument/2006/relationships" id="259" r:id="R11af637decd24e94"/>
-    <p:sldId xmlns:r="http://schemas.openxmlformats.org/officeDocument/2006/relationships" id="260" r:id="Rcc570fcc51e344cf"/>
-    <p:sldId xmlns:r="http://schemas.openxmlformats.org/officeDocument/2006/relationships" id="261" r:id="R807df4205209499a"/>
-    <p:sldId xmlns:r="http://schemas.openxmlformats.org/officeDocument/2006/relationships" id="262" r:id="R515d547bf7074d12"/>
-    <p:sldId xmlns:r="http://schemas.openxmlformats.org/officeDocument/2006/relationships" id="263" r:id="R3adfd61cf96e44b7"/>
-    <p:sldId xmlns:r="http://schemas.openxmlformats.org/officeDocument/2006/relationships" id="264" r:id="R97c1c58afe154cce"/>
-    <p:sldId xmlns:r="http://schemas.openxmlformats.org/officeDocument/2006/relationships" id="265" r:id="R4ac82eaa868042a3"/>
-    <p:sldId xmlns:r="http://schemas.openxmlformats.org/officeDocument/2006/relationships" id="266" r:id="Rd50f5d1df57446b1"/>
+    <p:sldId xmlns:r="http://schemas.openxmlformats.org/officeDocument/2006/relationships" id="256" r:id="R6a919e1b293340f6"/>
+    <p:sldId xmlns:r="http://schemas.openxmlformats.org/officeDocument/2006/relationships" id="257" r:id="R8f5e2d2373eb42b9"/>
+    <p:sldId xmlns:r="http://schemas.openxmlformats.org/officeDocument/2006/relationships" id="258" r:id="Rf12d6fc90bda4546"/>
+    <p:sldId xmlns:r="http://schemas.openxmlformats.org/officeDocument/2006/relationships" id="259" r:id="Re598ddb46eea4742"/>
+    <p:sldId xmlns:r="http://schemas.openxmlformats.org/officeDocument/2006/relationships" id="260" r:id="Reb047a0f7f554991"/>
+    <p:sldId xmlns:r="http://schemas.openxmlformats.org/officeDocument/2006/relationships" id="261" r:id="Re87b2281bd2e4664"/>
+    <p:sldId xmlns:r="http://schemas.openxmlformats.org/officeDocument/2006/relationships" id="262" r:id="Rc772109a97244f45"/>
+    <p:sldId xmlns:r="http://schemas.openxmlformats.org/officeDocument/2006/relationships" id="263" r:id="R6639a03be77a499d"/>
+    <p:sldId xmlns:r="http://schemas.openxmlformats.org/officeDocument/2006/relationships" id="264" r:id="R6f6382b0b2524afb"/>
+    <p:sldId xmlns:r="http://schemas.openxmlformats.org/officeDocument/2006/relationships" id="265" r:id="R4522327efc814979"/>
+    <p:sldId xmlns:r="http://schemas.openxmlformats.org/officeDocument/2006/relationships" id="266" r:id="Re0f75a015e0b453c"/>
   </p:sldIdLst>
   <p:sldSz cx="12192000" cy="6858000"/>
   <p:notesSz cx="6858000" cy="9144000"/>
@@ -1385,7 +1385,7 @@
   </p:cSld>
   <p:clrMap bg1="lt1" tx1="dk1" bg2="lt2" tx2="dk2" accent1="accent1" accent2="accent2" accent3="accent3" accent4="accent4" accent5="accent5" accent6="accent6" hlink="hlink" folHlink="folHlink"/>
   <p:sldLayoutIdLst>
-    <p:sldLayoutId xmlns:r="http://schemas.openxmlformats.org/officeDocument/2006/relationships" id="2147483649" r:id="R369e5de517194dcd"/>
+    <p:sldLayoutId xmlns:r="http://schemas.openxmlformats.org/officeDocument/2006/relationships" id="2147483649" r:id="R45f802833e7a4372"/>
   </p:sldLayoutIdLst>
   <p:txStyles>
     <p:titleStyle>
@@ -1936,7 +1936,7 @@
           <p:cNvPr id="8" name="">
             <a:extLst xmlns:a="http://schemas.openxmlformats.org/drawingml/2006/main">
               <a:ext uri="{FF2B5EF4-FFF2-40B4-BE49-F238E27FC236}">
-                <a16:creationId xmlns:a16="http://schemas.microsoft.com/office/drawing/2014/main" id="{57DE0A40-606A-4DB1-8519-9A9EED0E872C}"/>
+                <a16:creationId xmlns:a16="http://schemas.microsoft.com/office/drawing/2014/main" id="{295D127F-024F-41A6-BE9A-8AE905E0068E}"/>
               </a:ext>
             </a:extLst>
           </p:cNvPr>
@@ -1994,7 +1994,7 @@
           <p:cNvPr id="2" name="">
             <a:extLst xmlns:a="http://schemas.openxmlformats.org/drawingml/2006/main">
               <a:ext uri="{FF2B5EF4-FFF2-40B4-BE49-F238E27FC236}">
-                <a16:creationId xmlns:a16="http://schemas.microsoft.com/office/drawing/2014/main" id="{0854C656-38C8-437B-9380-0A1CC79CA41C}"/>
+                <a16:creationId xmlns:a16="http://schemas.microsoft.com/office/drawing/2014/main" id="{C70DF8F4-D5FD-4499-AA1E-B185A5392D7E}"/>
               </a:ext>
             </a:extLst>
           </p:cNvPr>
@@ -2052,7 +2052,7 @@
           <p:cNvPr id="3" name="">
             <a:extLst xmlns:a="http://schemas.openxmlformats.org/drawingml/2006/main">
               <a:ext uri="{FF2B5EF4-FFF2-40B4-BE49-F238E27FC236}">
-                <a16:creationId xmlns:a16="http://schemas.microsoft.com/office/drawing/2014/main" id="{B6FF119E-B4BC-4C4C-9F06-09972448A6F4}"/>
+                <a16:creationId xmlns:a16="http://schemas.microsoft.com/office/drawing/2014/main" id="{D338DE40-16C9-4BAD-A797-131140708A34}"/>
               </a:ext>
             </a:extLst>
           </p:cNvPr>
@@ -2110,7 +2110,7 @@
           <p:cNvPr id="4" name="">
             <a:extLst xmlns:a="http://schemas.openxmlformats.org/drawingml/2006/main">
               <a:ext uri="{FF2B5EF4-FFF2-40B4-BE49-F238E27FC236}">
-                <a16:creationId xmlns:a16="http://schemas.microsoft.com/office/drawing/2014/main" id="{EEB93B16-8972-479E-85A4-85C6170CE142}"/>
+                <a16:creationId xmlns:a16="http://schemas.microsoft.com/office/drawing/2014/main" id="{B810B1A9-4866-4B04-9811-690F480DA566}"/>
               </a:ext>
             </a:extLst>
           </p:cNvPr>
@@ -2141,7 +2141,7 @@
           <p:cNvPr id="5" name="">
             <a:extLst xmlns:a="http://schemas.openxmlformats.org/drawingml/2006/main">
               <a:ext uri="{FF2B5EF4-FFF2-40B4-BE49-F238E27FC236}">
-                <a16:creationId xmlns:a16="http://schemas.microsoft.com/office/drawing/2014/main" id="{83A19E54-604A-4E2A-82E5-0D93D42B384F}"/>
+                <a16:creationId xmlns:a16="http://schemas.microsoft.com/office/drawing/2014/main" id="{50781029-D8F2-4C3B-BF2E-6FA63E79ED86}"/>
               </a:ext>
             </a:extLst>
           </p:cNvPr>
@@ -2199,7 +2199,7 @@
           <p:cNvPr id="6" name="">
             <a:extLst xmlns:a="http://schemas.openxmlformats.org/drawingml/2006/main">
               <a:ext uri="{FF2B5EF4-FFF2-40B4-BE49-F238E27FC236}">
-                <a16:creationId xmlns:a16="http://schemas.microsoft.com/office/drawing/2014/main" id="{C9F1723D-A422-476D-A072-A44858FDB576}"/>
+                <a16:creationId xmlns:a16="http://schemas.microsoft.com/office/drawing/2014/main" id="{390AC806-64E6-4B83-B6ED-DE706E1D4297}"/>
               </a:ext>
             </a:extLst>
           </p:cNvPr>
@@ -2238,7 +2238,7 @@
           <p:nvPr/>
         </p:nvPicPr>
         <p:blipFill>
-          <a:blip xmlns:r="http://schemas.openxmlformats.org/officeDocument/2006/relationships" xmlns:a="http://schemas.openxmlformats.org/drawingml/2006/main" r:embed="R9a864c9151f64af7"/>
+          <a:blip xmlns:r="http://schemas.openxmlformats.org/officeDocument/2006/relationships" xmlns:a="http://schemas.openxmlformats.org/drawingml/2006/main" r:embed="R27113b59774742c7"/>
           <a:srcRect xmlns:a="http://schemas.openxmlformats.org/drawingml/2006/main" l="4252" t="0" r="4252" b="0"/>
           <a:stretch xmlns:a="http://schemas.openxmlformats.org/drawingml/2006/main">
             <a:fillRect l="0" t="0" r="0" b="0"/>
@@ -2259,7 +2259,7 @@
     </p:spTree>
     <p:extLst>
       <p:ext uri="{BB962C8B-B14F-4D97-AF65-F5344CB8AC3E}">
-        <p14:creationId xmlns:p14="http://schemas.microsoft.com/office/powerpoint/2010/main" val="1158197417"/>
+        <p14:creationId xmlns:p14="http://schemas.microsoft.com/office/powerpoint/2010/main" val="777711502"/>
       </p:ext>
     </p:extLst>
   </p:cSld>
@@ -2290,7 +2290,7 @@
           <p:cNvPr id="17" name="">
             <a:extLst xmlns:a="http://schemas.openxmlformats.org/drawingml/2006/main">
               <a:ext uri="{FF2B5EF4-FFF2-40B4-BE49-F238E27FC236}">
-                <a16:creationId xmlns:a16="http://schemas.microsoft.com/office/drawing/2014/main" id="{0A617941-B451-458B-8D40-750B269F855D}"/>
+                <a16:creationId xmlns:a16="http://schemas.microsoft.com/office/drawing/2014/main" id="{BE26F6CB-AC66-440F-ACE7-04B20D2347C5}"/>
               </a:ext>
             </a:extLst>
           </p:cNvPr>
@@ -2348,7 +2348,7 @@
           <p:cNvPr id="2" name="">
             <a:extLst xmlns:a="http://schemas.openxmlformats.org/drawingml/2006/main">
               <a:ext uri="{FF2B5EF4-FFF2-40B4-BE49-F238E27FC236}">
-                <a16:creationId xmlns:a16="http://schemas.microsoft.com/office/drawing/2014/main" id="{A273D6D3-6E8B-42FE-8646-2014E4409B4F}"/>
+                <a16:creationId xmlns:a16="http://schemas.microsoft.com/office/drawing/2014/main" id="{B34742B3-7CBA-4D05-9E55-FCE9D4DA0F51}"/>
               </a:ext>
             </a:extLst>
           </p:cNvPr>
@@ -2406,7 +2406,7 @@
           <p:cNvPr id="3" name="">
             <a:extLst xmlns:a="http://schemas.openxmlformats.org/drawingml/2006/main">
               <a:ext uri="{FF2B5EF4-FFF2-40B4-BE49-F238E27FC236}">
-                <a16:creationId xmlns:a16="http://schemas.microsoft.com/office/drawing/2014/main" id="{C20E98AB-EF8C-4BB3-A22D-1DDF32144FD4}"/>
+                <a16:creationId xmlns:a16="http://schemas.microsoft.com/office/drawing/2014/main" id="{6F01A7D1-295F-4F15-804F-0B953D77A9EC}"/>
               </a:ext>
             </a:extLst>
           </p:cNvPr>
@@ -2464,7 +2464,7 @@
           <p:cNvPr id="4" name="">
             <a:extLst xmlns:a="http://schemas.openxmlformats.org/drawingml/2006/main">
               <a:ext uri="{FF2B5EF4-FFF2-40B4-BE49-F238E27FC236}">
-                <a16:creationId xmlns:a16="http://schemas.microsoft.com/office/drawing/2014/main" id="{218AFF5A-51E1-4093-95E7-700CD6D8B77C}"/>
+                <a16:creationId xmlns:a16="http://schemas.microsoft.com/office/drawing/2014/main" id="{78CD0E94-0C52-4A22-A52F-0D322F3C92FF}"/>
               </a:ext>
             </a:extLst>
           </p:cNvPr>
@@ -2522,7 +2522,7 @@
           <p:cNvPr id="5" name="">
             <a:extLst xmlns:a="http://schemas.openxmlformats.org/drawingml/2006/main">
               <a:ext uri="{FF2B5EF4-FFF2-40B4-BE49-F238E27FC236}">
-                <a16:creationId xmlns:a16="http://schemas.microsoft.com/office/drawing/2014/main" id="{78FF0E87-4D9B-44A3-A59E-B3AB23A70B99}"/>
+                <a16:creationId xmlns:a16="http://schemas.microsoft.com/office/drawing/2014/main" id="{2C2F0F35-9D51-4F6D-B751-271BEFAC5642}"/>
               </a:ext>
             </a:extLst>
           </p:cNvPr>
@@ -2555,7 +2555,7 @@
           <p:cNvPr id="6" name="">
             <a:extLst xmlns:a="http://schemas.openxmlformats.org/drawingml/2006/main">
               <a:ext uri="{FF2B5EF4-FFF2-40B4-BE49-F238E27FC236}">
-                <a16:creationId xmlns:a16="http://schemas.microsoft.com/office/drawing/2014/main" id="{7648B4B8-4CCD-41E8-B0EB-9741CA07169F}"/>
+                <a16:creationId xmlns:a16="http://schemas.microsoft.com/office/drawing/2014/main" id="{C81D2F9E-EBCB-43A7-97AA-C9B3BC76C02D}"/>
               </a:ext>
             </a:extLst>
           </p:cNvPr>
@@ -2613,7 +2613,7 @@
           <p:cNvPr id="7" name="">
             <a:extLst xmlns:a="http://schemas.openxmlformats.org/drawingml/2006/main">
               <a:ext uri="{FF2B5EF4-FFF2-40B4-BE49-F238E27FC236}">
-                <a16:creationId xmlns:a16="http://schemas.microsoft.com/office/drawing/2014/main" id="{6AF71BCE-B14D-415D-8D11-CF656788C37F}"/>
+                <a16:creationId xmlns:a16="http://schemas.microsoft.com/office/drawing/2014/main" id="{31301827-7FC1-4BE1-90B0-2EE11DC5F8B1}"/>
               </a:ext>
             </a:extLst>
           </p:cNvPr>
@@ -2671,7 +2671,7 @@
           <p:cNvPr id="8" name="">
             <a:extLst xmlns:a="http://schemas.openxmlformats.org/drawingml/2006/main">
               <a:ext uri="{FF2B5EF4-FFF2-40B4-BE49-F238E27FC236}">
-                <a16:creationId xmlns:a16="http://schemas.microsoft.com/office/drawing/2014/main" id="{EFF76295-D937-412E-8196-DCE4A5201D4C}"/>
+                <a16:creationId xmlns:a16="http://schemas.microsoft.com/office/drawing/2014/main" id="{50984547-85AE-4C32-A610-DB9AD2A89532}"/>
               </a:ext>
             </a:extLst>
           </p:cNvPr>
@@ -2729,7 +2729,7 @@
           <p:cNvPr id="9" name="">
             <a:extLst xmlns:a="http://schemas.openxmlformats.org/drawingml/2006/main">
               <a:ext uri="{FF2B5EF4-FFF2-40B4-BE49-F238E27FC236}">
-                <a16:creationId xmlns:a16="http://schemas.microsoft.com/office/drawing/2014/main" id="{989CBF0E-9489-4CB5-9B50-932B4E53BD13}"/>
+                <a16:creationId xmlns:a16="http://schemas.microsoft.com/office/drawing/2014/main" id="{406441F7-E70F-4C8D-937E-FA7EA1913F96}"/>
               </a:ext>
             </a:extLst>
           </p:cNvPr>
@@ -2762,7 +2762,7 @@
           <p:cNvPr id="10" name="">
             <a:extLst xmlns:a="http://schemas.openxmlformats.org/drawingml/2006/main">
               <a:ext uri="{FF2B5EF4-FFF2-40B4-BE49-F238E27FC236}">
-                <a16:creationId xmlns:a16="http://schemas.microsoft.com/office/drawing/2014/main" id="{7D324AA6-5577-4671-8DE6-8CF31B99DF58}"/>
+                <a16:creationId xmlns:a16="http://schemas.microsoft.com/office/drawing/2014/main" id="{6DA6ACE3-FFFB-4F67-9B66-CCDEFCB70D47}"/>
               </a:ext>
             </a:extLst>
           </p:cNvPr>
@@ -2820,7 +2820,7 @@
           <p:cNvPr id="11" name="">
             <a:extLst xmlns:a="http://schemas.openxmlformats.org/drawingml/2006/main">
               <a:ext uri="{FF2B5EF4-FFF2-40B4-BE49-F238E27FC236}">
-                <a16:creationId xmlns:a16="http://schemas.microsoft.com/office/drawing/2014/main" id="{718BA223-B477-40E0-AF7E-54D3609819F7}"/>
+                <a16:creationId xmlns:a16="http://schemas.microsoft.com/office/drawing/2014/main" id="{3596C34D-3636-49FC-9A00-1DECFCD21F0C}"/>
               </a:ext>
             </a:extLst>
           </p:cNvPr>
@@ -2878,7 +2878,7 @@
           <p:cNvPr id="12" name="">
             <a:extLst xmlns:a="http://schemas.openxmlformats.org/drawingml/2006/main">
               <a:ext uri="{FF2B5EF4-FFF2-40B4-BE49-F238E27FC236}">
-                <a16:creationId xmlns:a16="http://schemas.microsoft.com/office/drawing/2014/main" id="{FAFAE3C2-9DDE-4F0C-80C5-54C658C00218}"/>
+                <a16:creationId xmlns:a16="http://schemas.microsoft.com/office/drawing/2014/main" id="{F823BE93-557B-4B2D-A596-37F6800BBDCB}"/>
               </a:ext>
             </a:extLst>
           </p:cNvPr>
@@ -2936,7 +2936,7 @@
           <p:cNvPr id="13" name="">
             <a:extLst xmlns:a="http://schemas.openxmlformats.org/drawingml/2006/main">
               <a:ext uri="{FF2B5EF4-FFF2-40B4-BE49-F238E27FC236}">
-                <a16:creationId xmlns:a16="http://schemas.microsoft.com/office/drawing/2014/main" id="{4717B568-2182-43F7-AD4F-1175575599C6}"/>
+                <a16:creationId xmlns:a16="http://schemas.microsoft.com/office/drawing/2014/main" id="{0068DB7E-78FA-47FB-85A7-B1B4A3A70C49}"/>
               </a:ext>
             </a:extLst>
           </p:cNvPr>
@@ -2969,7 +2969,7 @@
           <p:cNvPr id="14" name="">
             <a:extLst xmlns:a="http://schemas.openxmlformats.org/drawingml/2006/main">
               <a:ext uri="{FF2B5EF4-FFF2-40B4-BE49-F238E27FC236}">
-                <a16:creationId xmlns:a16="http://schemas.microsoft.com/office/drawing/2014/main" id="{E47D0459-C039-415E-A127-DBECF3AE37AA}"/>
+                <a16:creationId xmlns:a16="http://schemas.microsoft.com/office/drawing/2014/main" id="{DCF94C03-71D9-430D-8425-B4A2F180F4C4}"/>
               </a:ext>
             </a:extLst>
           </p:cNvPr>
@@ -3027,7 +3027,7 @@
           <p:cNvPr id="15" name="">
             <a:extLst xmlns:a="http://schemas.openxmlformats.org/drawingml/2006/main">
               <a:ext uri="{FF2B5EF4-FFF2-40B4-BE49-F238E27FC236}">
-                <a16:creationId xmlns:a16="http://schemas.microsoft.com/office/drawing/2014/main" id="{CD800296-C70E-4A69-BFC2-FF6D1AD3185B}"/>
+                <a16:creationId xmlns:a16="http://schemas.microsoft.com/office/drawing/2014/main" id="{E4E1566D-162B-4CE5-860C-0E7AB54A8774}"/>
               </a:ext>
             </a:extLst>
           </p:cNvPr>
@@ -3085,7 +3085,7 @@
           <p:cNvPr id="16" name="">
             <a:extLst xmlns:a="http://schemas.openxmlformats.org/drawingml/2006/main">
               <a:ext uri="{FF2B5EF4-FFF2-40B4-BE49-F238E27FC236}">
-                <a16:creationId xmlns:a16="http://schemas.microsoft.com/office/drawing/2014/main" id="{F4D6680A-AD08-462A-8A02-723241FAE16C}"/>
+                <a16:creationId xmlns:a16="http://schemas.microsoft.com/office/drawing/2014/main" id="{E55E2FB1-9749-4C9D-8B5E-FB4FFED6711A}"/>
               </a:ext>
             </a:extLst>
           </p:cNvPr>
@@ -3141,7 +3141,7 @@
     </p:spTree>
     <p:extLst>
       <p:ext uri="{BB962C8B-B14F-4D97-AF65-F5344CB8AC3E}">
-        <p14:creationId xmlns:p14="http://schemas.microsoft.com/office/powerpoint/2010/main" val="2140922709"/>
+        <p14:creationId xmlns:p14="http://schemas.microsoft.com/office/powerpoint/2010/main" val="768892905"/>
       </p:ext>
     </p:extLst>
   </p:cSld>
@@ -3172,7 +3172,7 @@
           <p:cNvPr id="19" name="">
             <a:extLst xmlns:a="http://schemas.openxmlformats.org/drawingml/2006/main">
               <a:ext uri="{FF2B5EF4-FFF2-40B4-BE49-F238E27FC236}">
-                <a16:creationId xmlns:a16="http://schemas.microsoft.com/office/drawing/2014/main" id="{FA94B116-2AB3-46B3-A23E-C1B60954F575}"/>
+                <a16:creationId xmlns:a16="http://schemas.microsoft.com/office/drawing/2014/main" id="{CCCFF2D1-A5F4-4D2F-80B4-15DA3CB5E510}"/>
               </a:ext>
             </a:extLst>
           </p:cNvPr>
@@ -3230,7 +3230,7 @@
           <p:cNvPr id="2" name="">
             <a:extLst xmlns:a="http://schemas.openxmlformats.org/drawingml/2006/main">
               <a:ext uri="{FF2B5EF4-FFF2-40B4-BE49-F238E27FC236}">
-                <a16:creationId xmlns:a16="http://schemas.microsoft.com/office/drawing/2014/main" id="{78089C18-CFA4-454F-8642-5FFF8F2EC93B}"/>
+                <a16:creationId xmlns:a16="http://schemas.microsoft.com/office/drawing/2014/main" id="{167FDBF1-B188-4605-92A9-BE9FC432B523}"/>
               </a:ext>
             </a:extLst>
           </p:cNvPr>
@@ -3288,7 +3288,7 @@
           <p:cNvPr id="3" name="">
             <a:extLst xmlns:a="http://schemas.openxmlformats.org/drawingml/2006/main">
               <a:ext uri="{FF2B5EF4-FFF2-40B4-BE49-F238E27FC236}">
-                <a16:creationId xmlns:a16="http://schemas.microsoft.com/office/drawing/2014/main" id="{60524180-1DD8-4765-B863-0E22E0AE5785}"/>
+                <a16:creationId xmlns:a16="http://schemas.microsoft.com/office/drawing/2014/main" id="{3C1DAC09-6097-459D-8EB7-E4A25848090F}"/>
               </a:ext>
             </a:extLst>
           </p:cNvPr>
@@ -3346,7 +3346,7 @@
           <p:cNvPr id="4" name="">
             <a:extLst xmlns:a="http://schemas.openxmlformats.org/drawingml/2006/main">
               <a:ext uri="{FF2B5EF4-FFF2-40B4-BE49-F238E27FC236}">
-                <a16:creationId xmlns:a16="http://schemas.microsoft.com/office/drawing/2014/main" id="{3D932D38-7D52-4F39-8899-F3F990693C57}"/>
+                <a16:creationId xmlns:a16="http://schemas.microsoft.com/office/drawing/2014/main" id="{E27D8BE6-FE31-4C3B-854C-73A0781296F2}"/>
               </a:ext>
             </a:extLst>
           </p:cNvPr>
@@ -3379,7 +3379,7 @@
           <p:cNvPr id="5" name="">
             <a:extLst xmlns:a="http://schemas.openxmlformats.org/drawingml/2006/main">
               <a:ext uri="{FF2B5EF4-FFF2-40B4-BE49-F238E27FC236}">
-                <a16:creationId xmlns:a16="http://schemas.microsoft.com/office/drawing/2014/main" id="{E835E56E-9F95-49CB-B56A-482289A22EC0}"/>
+                <a16:creationId xmlns:a16="http://schemas.microsoft.com/office/drawing/2014/main" id="{F7029A9C-1D8C-4EE7-A6CC-E8F3650F6EE5}"/>
               </a:ext>
             </a:extLst>
           </p:cNvPr>
@@ -3437,7 +3437,7 @@
           <p:cNvPr id="6" name="">
             <a:extLst xmlns:a="http://schemas.openxmlformats.org/drawingml/2006/main">
               <a:ext uri="{FF2B5EF4-FFF2-40B4-BE49-F238E27FC236}">
-                <a16:creationId xmlns:a16="http://schemas.microsoft.com/office/drawing/2014/main" id="{C32712ED-786C-424F-8A22-CCE4E384CF07}"/>
+                <a16:creationId xmlns:a16="http://schemas.microsoft.com/office/drawing/2014/main" id="{361E293E-442C-4466-A757-AFAA6D29F8A2}"/>
               </a:ext>
             </a:extLst>
           </p:cNvPr>
@@ -3495,7 +3495,7 @@
           <p:cNvPr id="7" name="">
             <a:extLst xmlns:a="http://schemas.openxmlformats.org/drawingml/2006/main">
               <a:ext uri="{FF2B5EF4-FFF2-40B4-BE49-F238E27FC236}">
-                <a16:creationId xmlns:a16="http://schemas.microsoft.com/office/drawing/2014/main" id="{BE0AD1AE-280A-4FB6-A5D5-85E42E6B4B6A}"/>
+                <a16:creationId xmlns:a16="http://schemas.microsoft.com/office/drawing/2014/main" id="{E65444EF-BEFD-4E1A-ADF6-437AA00D6F06}"/>
               </a:ext>
             </a:extLst>
           </p:cNvPr>
@@ -3528,7 +3528,7 @@
           <p:cNvPr id="8" name="">
             <a:extLst xmlns:a="http://schemas.openxmlformats.org/drawingml/2006/main">
               <a:ext uri="{FF2B5EF4-FFF2-40B4-BE49-F238E27FC236}">
-                <a16:creationId xmlns:a16="http://schemas.microsoft.com/office/drawing/2014/main" id="{02445E38-2593-4EB6-8825-CCAA964A0452}"/>
+                <a16:creationId xmlns:a16="http://schemas.microsoft.com/office/drawing/2014/main" id="{CC8E6063-552C-4240-ABC5-C4353845A3F9}"/>
               </a:ext>
             </a:extLst>
           </p:cNvPr>
@@ -3586,7 +3586,7 @@
           <p:cNvPr id="9" name="">
             <a:extLst xmlns:a="http://schemas.openxmlformats.org/drawingml/2006/main">
               <a:ext uri="{FF2B5EF4-FFF2-40B4-BE49-F238E27FC236}">
-                <a16:creationId xmlns:a16="http://schemas.microsoft.com/office/drawing/2014/main" id="{29C4FE80-4DB4-455E-8D8B-CD1430164E9F}"/>
+                <a16:creationId xmlns:a16="http://schemas.microsoft.com/office/drawing/2014/main" id="{59DFB63E-81CB-474A-BD2B-0FA043787D42}"/>
               </a:ext>
             </a:extLst>
           </p:cNvPr>
@@ -3644,7 +3644,7 @@
           <p:cNvPr id="10" name="">
             <a:extLst xmlns:a="http://schemas.openxmlformats.org/drawingml/2006/main">
               <a:ext uri="{FF2B5EF4-FFF2-40B4-BE49-F238E27FC236}">
-                <a16:creationId xmlns:a16="http://schemas.microsoft.com/office/drawing/2014/main" id="{73AE1FA1-97F0-4EBB-8798-0E717FA6C771}"/>
+                <a16:creationId xmlns:a16="http://schemas.microsoft.com/office/drawing/2014/main" id="{5C864111-EA71-4CAB-81A4-FBDEB13430B0}"/>
               </a:ext>
             </a:extLst>
           </p:cNvPr>
@@ -3677,7 +3677,7 @@
           <p:cNvPr id="11" name="">
             <a:extLst xmlns:a="http://schemas.openxmlformats.org/drawingml/2006/main">
               <a:ext uri="{FF2B5EF4-FFF2-40B4-BE49-F238E27FC236}">
-                <a16:creationId xmlns:a16="http://schemas.microsoft.com/office/drawing/2014/main" id="{21901284-93D6-4D3C-A667-FB8CF9FFC48A}"/>
+                <a16:creationId xmlns:a16="http://schemas.microsoft.com/office/drawing/2014/main" id="{DE586C31-E345-48AE-A20B-B5C8CD373434}"/>
               </a:ext>
             </a:extLst>
           </p:cNvPr>
@@ -3735,7 +3735,7 @@
           <p:cNvPr id="12" name="">
             <a:extLst xmlns:a="http://schemas.openxmlformats.org/drawingml/2006/main">
               <a:ext uri="{FF2B5EF4-FFF2-40B4-BE49-F238E27FC236}">
-                <a16:creationId xmlns:a16="http://schemas.microsoft.com/office/drawing/2014/main" id="{F0973DAB-439C-4F5D-824F-8D9A685F6FF5}"/>
+                <a16:creationId xmlns:a16="http://schemas.microsoft.com/office/drawing/2014/main" id="{11864E39-6C8C-4D49-969B-EA9BEF0EABA5}"/>
               </a:ext>
             </a:extLst>
           </p:cNvPr>
@@ -3793,7 +3793,7 @@
           <p:cNvPr id="13" name="">
             <a:extLst xmlns:a="http://schemas.openxmlformats.org/drawingml/2006/main">
               <a:ext uri="{FF2B5EF4-FFF2-40B4-BE49-F238E27FC236}">
-                <a16:creationId xmlns:a16="http://schemas.microsoft.com/office/drawing/2014/main" id="{02EC7CB4-594B-4FF6-98B5-6B22366244A5}"/>
+                <a16:creationId xmlns:a16="http://schemas.microsoft.com/office/drawing/2014/main" id="{704B6280-FE5B-4495-9F2A-D860A6C0CE32}"/>
               </a:ext>
             </a:extLst>
           </p:cNvPr>
@@ -3826,7 +3826,7 @@
           <p:cNvPr id="14" name="">
             <a:extLst xmlns:a="http://schemas.openxmlformats.org/drawingml/2006/main">
               <a:ext uri="{FF2B5EF4-FFF2-40B4-BE49-F238E27FC236}">
-                <a16:creationId xmlns:a16="http://schemas.microsoft.com/office/drawing/2014/main" id="{824AA036-C698-46EF-BCF4-361782BAA858}"/>
+                <a16:creationId xmlns:a16="http://schemas.microsoft.com/office/drawing/2014/main" id="{33053B8A-C125-4628-8148-C4140DDB6033}"/>
               </a:ext>
             </a:extLst>
           </p:cNvPr>
@@ -3884,7 +3884,7 @@
           <p:cNvPr id="15" name="">
             <a:extLst xmlns:a="http://schemas.openxmlformats.org/drawingml/2006/main">
               <a:ext uri="{FF2B5EF4-FFF2-40B4-BE49-F238E27FC236}">
-                <a16:creationId xmlns:a16="http://schemas.microsoft.com/office/drawing/2014/main" id="{1063552A-F552-4F6D-9503-F058D7C7F335}"/>
+                <a16:creationId xmlns:a16="http://schemas.microsoft.com/office/drawing/2014/main" id="{15922404-392B-4520-AAFA-02A2D8573C5E}"/>
               </a:ext>
             </a:extLst>
           </p:cNvPr>
@@ -3942,7 +3942,7 @@
           <p:cNvPr id="16" name="">
             <a:extLst xmlns:a="http://schemas.openxmlformats.org/drawingml/2006/main">
               <a:ext uri="{FF2B5EF4-FFF2-40B4-BE49-F238E27FC236}">
-                <a16:creationId xmlns:a16="http://schemas.microsoft.com/office/drawing/2014/main" id="{A95FF18E-D3B2-4248-8C94-B6EC229C2C3D}"/>
+                <a16:creationId xmlns:a16="http://schemas.microsoft.com/office/drawing/2014/main" id="{4C011927-7446-4A9B-A2DB-945658A036E4}"/>
               </a:ext>
             </a:extLst>
           </p:cNvPr>
@@ -3973,7 +3973,7 @@
           <p:cNvPr id="17" name="">
             <a:extLst xmlns:a="http://schemas.openxmlformats.org/drawingml/2006/main">
               <a:ext uri="{FF2B5EF4-FFF2-40B4-BE49-F238E27FC236}">
-                <a16:creationId xmlns:a16="http://schemas.microsoft.com/office/drawing/2014/main" id="{247D0A32-F3BD-4B17-8347-27B5331CB861}"/>
+                <a16:creationId xmlns:a16="http://schemas.microsoft.com/office/drawing/2014/main" id="{AD92D4A2-91B4-4FFD-9097-C3CC49160DF4}"/>
               </a:ext>
             </a:extLst>
           </p:cNvPr>
@@ -4031,7 +4031,7 @@
           <p:cNvPr id="18" name="">
             <a:extLst xmlns:a="http://schemas.openxmlformats.org/drawingml/2006/main">
               <a:ext uri="{FF2B5EF4-FFF2-40B4-BE49-F238E27FC236}">
-                <a16:creationId xmlns:a16="http://schemas.microsoft.com/office/drawing/2014/main" id="{1158288F-543B-40F0-8C52-A2D93DE2D878}"/>
+                <a16:creationId xmlns:a16="http://schemas.microsoft.com/office/drawing/2014/main" id="{D65D8757-F928-4792-A91D-AAA4944F9648}"/>
               </a:ext>
             </a:extLst>
           </p:cNvPr>
@@ -4087,7 +4087,7 @@
     </p:spTree>
     <p:extLst>
       <p:ext uri="{BB962C8B-B14F-4D97-AF65-F5344CB8AC3E}">
-        <p14:creationId xmlns:p14="http://schemas.microsoft.com/office/powerpoint/2010/main" val="1480791929"/>
+        <p14:creationId xmlns:p14="http://schemas.microsoft.com/office/powerpoint/2010/main" val="828907884"/>
       </p:ext>
     </p:extLst>
   </p:cSld>
@@ -4118,7 +4118,7 @@
           <p:cNvPr id="17" name="">
             <a:extLst xmlns:a="http://schemas.openxmlformats.org/drawingml/2006/main">
               <a:ext uri="{FF2B5EF4-FFF2-40B4-BE49-F238E27FC236}">
-                <a16:creationId xmlns:a16="http://schemas.microsoft.com/office/drawing/2014/main" id="{53582200-A059-40E1-8173-E45EE1EB5A70}"/>
+                <a16:creationId xmlns:a16="http://schemas.microsoft.com/office/drawing/2014/main" id="{E90EF275-0C64-4B47-B913-9CC9E4E78997}"/>
               </a:ext>
             </a:extLst>
           </p:cNvPr>
@@ -4176,7 +4176,7 @@
           <p:cNvPr id="2" name="">
             <a:extLst xmlns:a="http://schemas.openxmlformats.org/drawingml/2006/main">
               <a:ext uri="{FF2B5EF4-FFF2-40B4-BE49-F238E27FC236}">
-                <a16:creationId xmlns:a16="http://schemas.microsoft.com/office/drawing/2014/main" id="{3A48D5BF-BA53-4473-AAB4-D0A02C16CDFE}"/>
+                <a16:creationId xmlns:a16="http://schemas.microsoft.com/office/drawing/2014/main" id="{3EA49BDB-0579-42E1-9AE8-E464C6CF320E}"/>
               </a:ext>
             </a:extLst>
           </p:cNvPr>
@@ -4234,7 +4234,7 @@
           <p:cNvPr id="3" name="">
             <a:extLst xmlns:a="http://schemas.openxmlformats.org/drawingml/2006/main">
               <a:ext uri="{FF2B5EF4-FFF2-40B4-BE49-F238E27FC236}">
-                <a16:creationId xmlns:a16="http://schemas.microsoft.com/office/drawing/2014/main" id="{FE45A45B-BD6C-46E3-9BD3-FF62DED944CA}"/>
+                <a16:creationId xmlns:a16="http://schemas.microsoft.com/office/drawing/2014/main" id="{6208EC39-F71F-4718-8680-C3D3AEFB00FE}"/>
               </a:ext>
             </a:extLst>
           </p:cNvPr>
@@ -4292,7 +4292,7 @@
           <p:cNvPr id="4" name="">
             <a:extLst xmlns:a="http://schemas.openxmlformats.org/drawingml/2006/main">
               <a:ext uri="{FF2B5EF4-FFF2-40B4-BE49-F238E27FC236}">
-                <a16:creationId xmlns:a16="http://schemas.microsoft.com/office/drawing/2014/main" id="{6640300F-F198-43E5-B73F-0EF68F88EF4A}"/>
+                <a16:creationId xmlns:a16="http://schemas.microsoft.com/office/drawing/2014/main" id="{DE246100-587C-4741-8EEE-B6C253A6BD24}"/>
               </a:ext>
             </a:extLst>
           </p:cNvPr>
@@ -4350,7 +4350,7 @@
           <p:cNvPr id="5" name="">
             <a:extLst xmlns:a="http://schemas.openxmlformats.org/drawingml/2006/main">
               <a:ext uri="{FF2B5EF4-FFF2-40B4-BE49-F238E27FC236}">
-                <a16:creationId xmlns:a16="http://schemas.microsoft.com/office/drawing/2014/main" id="{3ECD2C55-895A-47C9-ABC7-1297A7884C5E}"/>
+                <a16:creationId xmlns:a16="http://schemas.microsoft.com/office/drawing/2014/main" id="{7397A51C-1CC4-44A6-8320-81B01F2944EF}"/>
               </a:ext>
             </a:extLst>
           </p:cNvPr>
@@ -4383,7 +4383,7 @@
           <p:cNvPr id="6" name="">
             <a:extLst xmlns:a="http://schemas.openxmlformats.org/drawingml/2006/main">
               <a:ext uri="{FF2B5EF4-FFF2-40B4-BE49-F238E27FC236}">
-                <a16:creationId xmlns:a16="http://schemas.microsoft.com/office/drawing/2014/main" id="{76B3B9D0-6145-4689-81F2-0B6CC46F9B99}"/>
+                <a16:creationId xmlns:a16="http://schemas.microsoft.com/office/drawing/2014/main" id="{C824FB1A-9051-4AD0-ACEE-E3C1891070D5}"/>
               </a:ext>
             </a:extLst>
           </p:cNvPr>
@@ -4441,7 +4441,7 @@
           <p:cNvPr id="7" name="">
             <a:extLst xmlns:a="http://schemas.openxmlformats.org/drawingml/2006/main">
               <a:ext uri="{FF2B5EF4-FFF2-40B4-BE49-F238E27FC236}">
-                <a16:creationId xmlns:a16="http://schemas.microsoft.com/office/drawing/2014/main" id="{E1C21851-3AD7-4A69-B392-9F5C6E5B53BF}"/>
+                <a16:creationId xmlns:a16="http://schemas.microsoft.com/office/drawing/2014/main" id="{87A60CFC-6E61-4D34-9BCB-41B33FA2DCFB}"/>
               </a:ext>
             </a:extLst>
           </p:cNvPr>
@@ -4499,7 +4499,7 @@
           <p:cNvPr id="8" name="">
             <a:extLst xmlns:a="http://schemas.openxmlformats.org/drawingml/2006/main">
               <a:ext uri="{FF2B5EF4-FFF2-40B4-BE49-F238E27FC236}">
-                <a16:creationId xmlns:a16="http://schemas.microsoft.com/office/drawing/2014/main" id="{03CEEC09-8229-452F-8F7B-A7D88D6FB205}"/>
+                <a16:creationId xmlns:a16="http://schemas.microsoft.com/office/drawing/2014/main" id="{8877BB4A-3D16-42F2-951D-5C8C1FCE16BB}"/>
               </a:ext>
             </a:extLst>
           </p:cNvPr>
@@ -4557,7 +4557,7 @@
           <p:cNvPr id="9" name="">
             <a:extLst xmlns:a="http://schemas.openxmlformats.org/drawingml/2006/main">
               <a:ext uri="{FF2B5EF4-FFF2-40B4-BE49-F238E27FC236}">
-                <a16:creationId xmlns:a16="http://schemas.microsoft.com/office/drawing/2014/main" id="{1BB898F3-C73A-4668-992C-D12596A0C052}"/>
+                <a16:creationId xmlns:a16="http://schemas.microsoft.com/office/drawing/2014/main" id="{661B433C-B5B6-44C2-8898-54B2164379A4}"/>
               </a:ext>
             </a:extLst>
           </p:cNvPr>
@@ -4590,7 +4590,7 @@
           <p:cNvPr id="10" name="">
             <a:extLst xmlns:a="http://schemas.openxmlformats.org/drawingml/2006/main">
               <a:ext uri="{FF2B5EF4-FFF2-40B4-BE49-F238E27FC236}">
-                <a16:creationId xmlns:a16="http://schemas.microsoft.com/office/drawing/2014/main" id="{AA3FF277-F939-40F4-974B-AA749AB2591D}"/>
+                <a16:creationId xmlns:a16="http://schemas.microsoft.com/office/drawing/2014/main" id="{6050E5C9-D76B-4FD9-950C-73B6A20FB366}"/>
               </a:ext>
             </a:extLst>
           </p:cNvPr>
@@ -4648,7 +4648,7 @@
           <p:cNvPr id="11" name="">
             <a:extLst xmlns:a="http://schemas.openxmlformats.org/drawingml/2006/main">
               <a:ext uri="{FF2B5EF4-FFF2-40B4-BE49-F238E27FC236}">
-                <a16:creationId xmlns:a16="http://schemas.microsoft.com/office/drawing/2014/main" id="{92F314B6-E6FB-4504-8658-AE4D71BC3019}"/>
+                <a16:creationId xmlns:a16="http://schemas.microsoft.com/office/drawing/2014/main" id="{981C0A04-BA2B-4C70-9A0F-0C376F1B2376}"/>
               </a:ext>
             </a:extLst>
           </p:cNvPr>
@@ -4706,7 +4706,7 @@
           <p:cNvPr id="12" name="">
             <a:extLst xmlns:a="http://schemas.openxmlformats.org/drawingml/2006/main">
               <a:ext uri="{FF2B5EF4-FFF2-40B4-BE49-F238E27FC236}">
-                <a16:creationId xmlns:a16="http://schemas.microsoft.com/office/drawing/2014/main" id="{DB03A69B-7DCE-4EDF-BD83-15B8A3EB338A}"/>
+                <a16:creationId xmlns:a16="http://schemas.microsoft.com/office/drawing/2014/main" id="{F5DE9ECE-7A5D-44E2-9A25-6D651CCF9734}"/>
               </a:ext>
             </a:extLst>
           </p:cNvPr>
@@ -4764,7 +4764,7 @@
           <p:cNvPr id="13" name="">
             <a:extLst xmlns:a="http://schemas.openxmlformats.org/drawingml/2006/main">
               <a:ext uri="{FF2B5EF4-FFF2-40B4-BE49-F238E27FC236}">
-                <a16:creationId xmlns:a16="http://schemas.microsoft.com/office/drawing/2014/main" id="{14099F64-777D-4D6E-90EE-70007F6C130A}"/>
+                <a16:creationId xmlns:a16="http://schemas.microsoft.com/office/drawing/2014/main" id="{049FBD84-5FE7-4B5F-B043-109E6C2940D5}"/>
               </a:ext>
             </a:extLst>
           </p:cNvPr>
@@ -4797,7 +4797,7 @@
           <p:cNvPr id="14" name="">
             <a:extLst xmlns:a="http://schemas.openxmlformats.org/drawingml/2006/main">
               <a:ext uri="{FF2B5EF4-FFF2-40B4-BE49-F238E27FC236}">
-                <a16:creationId xmlns:a16="http://schemas.microsoft.com/office/drawing/2014/main" id="{A5F5FA0B-B9B8-4AD6-B6B9-160570A78D89}"/>
+                <a16:creationId xmlns:a16="http://schemas.microsoft.com/office/drawing/2014/main" id="{7405ECC7-287E-4AD3-9812-88E1DFA0C0ED}"/>
               </a:ext>
             </a:extLst>
           </p:cNvPr>
@@ -4855,7 +4855,7 @@
           <p:cNvPr id="15" name="">
             <a:extLst xmlns:a="http://schemas.openxmlformats.org/drawingml/2006/main">
               <a:ext uri="{FF2B5EF4-FFF2-40B4-BE49-F238E27FC236}">
-                <a16:creationId xmlns:a16="http://schemas.microsoft.com/office/drawing/2014/main" id="{4AB3A0A5-A527-4C8B-8BAA-77608A258328}"/>
+                <a16:creationId xmlns:a16="http://schemas.microsoft.com/office/drawing/2014/main" id="{785A1D1D-5BD5-4DDB-B248-AB7344E5CDE8}"/>
               </a:ext>
             </a:extLst>
           </p:cNvPr>
@@ -4913,7 +4913,7 @@
           <p:cNvPr id="16" name="">
             <a:extLst xmlns:a="http://schemas.openxmlformats.org/drawingml/2006/main">
               <a:ext uri="{FF2B5EF4-FFF2-40B4-BE49-F238E27FC236}">
-                <a16:creationId xmlns:a16="http://schemas.microsoft.com/office/drawing/2014/main" id="{C47839AB-F013-4DC2-A563-8B3B9B16E9E6}"/>
+                <a16:creationId xmlns:a16="http://schemas.microsoft.com/office/drawing/2014/main" id="{052639D9-A6C0-4BD5-93D5-57B160AFF0BC}"/>
               </a:ext>
             </a:extLst>
           </p:cNvPr>
@@ -4969,7 +4969,7 @@
     </p:spTree>
     <p:extLst>
       <p:ext uri="{BB962C8B-B14F-4D97-AF65-F5344CB8AC3E}">
-        <p14:creationId xmlns:p14="http://schemas.microsoft.com/office/powerpoint/2010/main" val="1569562958"/>
+        <p14:creationId xmlns:p14="http://schemas.microsoft.com/office/powerpoint/2010/main" val="1212321753"/>
       </p:ext>
     </p:extLst>
   </p:cSld>
@@ -5000,7 +5000,7 @@
           <p:cNvPr id="21" name="">
             <a:extLst xmlns:a="http://schemas.openxmlformats.org/drawingml/2006/main">
               <a:ext uri="{FF2B5EF4-FFF2-40B4-BE49-F238E27FC236}">
-                <a16:creationId xmlns:a16="http://schemas.microsoft.com/office/drawing/2014/main" id="{75D3EDFF-5E61-4390-8E80-845AEDC71829}"/>
+                <a16:creationId xmlns:a16="http://schemas.microsoft.com/office/drawing/2014/main" id="{63AE3507-4A7A-4245-8F81-745A2A87AF24}"/>
               </a:ext>
             </a:extLst>
           </p:cNvPr>
@@ -5058,7 +5058,7 @@
           <p:cNvPr id="2" name="">
             <a:extLst xmlns:a="http://schemas.openxmlformats.org/drawingml/2006/main">
               <a:ext uri="{FF2B5EF4-FFF2-40B4-BE49-F238E27FC236}">
-                <a16:creationId xmlns:a16="http://schemas.microsoft.com/office/drawing/2014/main" id="{6EC708E5-5BE4-4BF3-BBCD-AA801F8044F3}"/>
+                <a16:creationId xmlns:a16="http://schemas.microsoft.com/office/drawing/2014/main" id="{BFFC4B2F-8D9D-488B-8547-232FB114A6CD}"/>
               </a:ext>
             </a:extLst>
           </p:cNvPr>
@@ -5116,7 +5116,7 @@
           <p:cNvPr id="3" name="">
             <a:extLst xmlns:a="http://schemas.openxmlformats.org/drawingml/2006/main">
               <a:ext uri="{FF2B5EF4-FFF2-40B4-BE49-F238E27FC236}">
-                <a16:creationId xmlns:a16="http://schemas.microsoft.com/office/drawing/2014/main" id="{058BBBF9-CAA2-4098-BB3A-1DCFA7AB7E53}"/>
+                <a16:creationId xmlns:a16="http://schemas.microsoft.com/office/drawing/2014/main" id="{3C33A0DA-27F3-48B4-9BE3-B8187C8A3EA5}"/>
               </a:ext>
             </a:extLst>
           </p:cNvPr>
@@ -5174,7 +5174,7 @@
           <p:cNvPr id="4" name="">
             <a:extLst xmlns:a="http://schemas.openxmlformats.org/drawingml/2006/main">
               <a:ext uri="{FF2B5EF4-FFF2-40B4-BE49-F238E27FC236}">
-                <a16:creationId xmlns:a16="http://schemas.microsoft.com/office/drawing/2014/main" id="{12D891BF-FA73-40C7-8B75-4386BAC75D16}"/>
+                <a16:creationId xmlns:a16="http://schemas.microsoft.com/office/drawing/2014/main" id="{C9F30A80-A3A1-4209-867D-63347CF7E6D1}"/>
               </a:ext>
             </a:extLst>
           </p:cNvPr>
@@ -5232,7 +5232,7 @@
           <p:cNvPr id="5" name="">
             <a:extLst xmlns:a="http://schemas.openxmlformats.org/drawingml/2006/main">
               <a:ext uri="{FF2B5EF4-FFF2-40B4-BE49-F238E27FC236}">
-                <a16:creationId xmlns:a16="http://schemas.microsoft.com/office/drawing/2014/main" id="{1BA61BC9-927C-4DB7-9CF1-207C02BFCA5A}"/>
+                <a16:creationId xmlns:a16="http://schemas.microsoft.com/office/drawing/2014/main" id="{7D6C89EA-82AD-4217-BF40-27E5965E6699}"/>
               </a:ext>
             </a:extLst>
           </p:cNvPr>
@@ -5265,7 +5265,7 @@
           <p:cNvPr id="6" name="">
             <a:extLst xmlns:a="http://schemas.openxmlformats.org/drawingml/2006/main">
               <a:ext uri="{FF2B5EF4-FFF2-40B4-BE49-F238E27FC236}">
-                <a16:creationId xmlns:a16="http://schemas.microsoft.com/office/drawing/2014/main" id="{4E5A7C45-B0C3-4DE8-9B0E-4BB48F47E33F}"/>
+                <a16:creationId xmlns:a16="http://schemas.microsoft.com/office/drawing/2014/main" id="{4C4311A8-D2DE-4499-8C32-89C19A31E28A}"/>
               </a:ext>
             </a:extLst>
           </p:cNvPr>
@@ -5323,7 +5323,7 @@
           <p:cNvPr id="7" name="">
             <a:extLst xmlns:a="http://schemas.openxmlformats.org/drawingml/2006/main">
               <a:ext uri="{FF2B5EF4-FFF2-40B4-BE49-F238E27FC236}">
-                <a16:creationId xmlns:a16="http://schemas.microsoft.com/office/drawing/2014/main" id="{69103C0D-3077-481C-8E2D-71E964575714}"/>
+                <a16:creationId xmlns:a16="http://schemas.microsoft.com/office/drawing/2014/main" id="{F134F3AD-54BF-4F60-BB03-DCAB42D4CCBB}"/>
               </a:ext>
             </a:extLst>
           </p:cNvPr>
@@ -5381,7 +5381,7 @@
           <p:cNvPr id="8" name="">
             <a:extLst xmlns:a="http://schemas.openxmlformats.org/drawingml/2006/main">
               <a:ext uri="{FF2B5EF4-FFF2-40B4-BE49-F238E27FC236}">
-                <a16:creationId xmlns:a16="http://schemas.microsoft.com/office/drawing/2014/main" id="{47896322-FD24-4353-A710-5DD470F0C788}"/>
+                <a16:creationId xmlns:a16="http://schemas.microsoft.com/office/drawing/2014/main" id="{14C8A7E1-2A7D-42DA-9695-C2A7C5433CBA}"/>
               </a:ext>
             </a:extLst>
           </p:cNvPr>
@@ -5439,7 +5439,7 @@
           <p:cNvPr id="9" name="">
             <a:extLst xmlns:a="http://schemas.openxmlformats.org/drawingml/2006/main">
               <a:ext uri="{FF2B5EF4-FFF2-40B4-BE49-F238E27FC236}">
-                <a16:creationId xmlns:a16="http://schemas.microsoft.com/office/drawing/2014/main" id="{F5331E77-8CB0-4C2B-969E-FA0EBFB4E06B}"/>
+                <a16:creationId xmlns:a16="http://schemas.microsoft.com/office/drawing/2014/main" id="{4470B0C3-CBD2-450C-99FD-08670728BE65}"/>
               </a:ext>
             </a:extLst>
           </p:cNvPr>
@@ -5472,7 +5472,7 @@
           <p:cNvPr id="10" name="">
             <a:extLst xmlns:a="http://schemas.openxmlformats.org/drawingml/2006/main">
               <a:ext uri="{FF2B5EF4-FFF2-40B4-BE49-F238E27FC236}">
-                <a16:creationId xmlns:a16="http://schemas.microsoft.com/office/drawing/2014/main" id="{76097003-1504-4E49-A526-FB6A20247BFC}"/>
+                <a16:creationId xmlns:a16="http://schemas.microsoft.com/office/drawing/2014/main" id="{CCBC340A-CE64-4767-968E-E04977F3397B}"/>
               </a:ext>
             </a:extLst>
           </p:cNvPr>
@@ -5530,7 +5530,7 @@
           <p:cNvPr id="11" name="">
             <a:extLst xmlns:a="http://schemas.openxmlformats.org/drawingml/2006/main">
               <a:ext uri="{FF2B5EF4-FFF2-40B4-BE49-F238E27FC236}">
-                <a16:creationId xmlns:a16="http://schemas.microsoft.com/office/drawing/2014/main" id="{D1591CEF-943D-400F-AAE3-1271C60181D8}"/>
+                <a16:creationId xmlns:a16="http://schemas.microsoft.com/office/drawing/2014/main" id="{624C9C84-DC3B-4AE8-8BED-5219B8C764E3}"/>
               </a:ext>
             </a:extLst>
           </p:cNvPr>
@@ -5588,7 +5588,7 @@
           <p:cNvPr id="12" name="">
             <a:extLst xmlns:a="http://schemas.openxmlformats.org/drawingml/2006/main">
               <a:ext uri="{FF2B5EF4-FFF2-40B4-BE49-F238E27FC236}">
-                <a16:creationId xmlns:a16="http://schemas.microsoft.com/office/drawing/2014/main" id="{EEAF227D-A987-4B4F-AA28-A1D58A5CFE7B}"/>
+                <a16:creationId xmlns:a16="http://schemas.microsoft.com/office/drawing/2014/main" id="{CCFBD79C-1759-4A77-AD0F-A1B3072644F8}"/>
               </a:ext>
             </a:extLst>
           </p:cNvPr>
@@ -5646,7 +5646,7 @@
           <p:cNvPr id="13" name="">
             <a:extLst xmlns:a="http://schemas.openxmlformats.org/drawingml/2006/main">
               <a:ext uri="{FF2B5EF4-FFF2-40B4-BE49-F238E27FC236}">
-                <a16:creationId xmlns:a16="http://schemas.microsoft.com/office/drawing/2014/main" id="{83ABED67-A777-48AC-ACFE-1CC1A5842A69}"/>
+                <a16:creationId xmlns:a16="http://schemas.microsoft.com/office/drawing/2014/main" id="{B2085E21-CFF3-45EB-8EE8-70111E3842C5}"/>
               </a:ext>
             </a:extLst>
           </p:cNvPr>
@@ -5679,7 +5679,7 @@
           <p:cNvPr id="14" name="">
             <a:extLst xmlns:a="http://schemas.openxmlformats.org/drawingml/2006/main">
               <a:ext uri="{FF2B5EF4-FFF2-40B4-BE49-F238E27FC236}">
-                <a16:creationId xmlns:a16="http://schemas.microsoft.com/office/drawing/2014/main" id="{674C558F-F4DB-431C-861F-9627299DBAB2}"/>
+                <a16:creationId xmlns:a16="http://schemas.microsoft.com/office/drawing/2014/main" id="{0A0B744A-7233-4672-86BB-DEEBB021DC53}"/>
               </a:ext>
             </a:extLst>
           </p:cNvPr>
@@ -5737,7 +5737,7 @@
           <p:cNvPr id="15" name="">
             <a:extLst xmlns:a="http://schemas.openxmlformats.org/drawingml/2006/main">
               <a:ext uri="{FF2B5EF4-FFF2-40B4-BE49-F238E27FC236}">
-                <a16:creationId xmlns:a16="http://schemas.microsoft.com/office/drawing/2014/main" id="{365F76E9-288B-436F-B7AF-7C7483F38209}"/>
+                <a16:creationId xmlns:a16="http://schemas.microsoft.com/office/drawing/2014/main" id="{4854B65C-1FBD-48D7-8CE2-B9FBD2409C42}"/>
               </a:ext>
             </a:extLst>
           </p:cNvPr>
@@ -5795,7 +5795,7 @@
           <p:cNvPr id="16" name="">
             <a:extLst xmlns:a="http://schemas.openxmlformats.org/drawingml/2006/main">
               <a:ext uri="{FF2B5EF4-FFF2-40B4-BE49-F238E27FC236}">
-                <a16:creationId xmlns:a16="http://schemas.microsoft.com/office/drawing/2014/main" id="{376F36A0-B083-40AA-9E1F-64C2FE11F7B8}"/>
+                <a16:creationId xmlns:a16="http://schemas.microsoft.com/office/drawing/2014/main" id="{C2FA7FA9-6383-487C-8056-0B0A250B0220}"/>
               </a:ext>
             </a:extLst>
           </p:cNvPr>
@@ -5853,7 +5853,7 @@
           <p:cNvPr id="17" name="">
             <a:extLst xmlns:a="http://schemas.openxmlformats.org/drawingml/2006/main">
               <a:ext uri="{FF2B5EF4-FFF2-40B4-BE49-F238E27FC236}">
-                <a16:creationId xmlns:a16="http://schemas.microsoft.com/office/drawing/2014/main" id="{52C75B71-1337-4B58-8853-0829E7E3F346}"/>
+                <a16:creationId xmlns:a16="http://schemas.microsoft.com/office/drawing/2014/main" id="{EC59D732-F26E-438C-AB8F-5CED38291B97}"/>
               </a:ext>
             </a:extLst>
           </p:cNvPr>
@@ -5886,7 +5886,7 @@
           <p:cNvPr id="18" name="">
             <a:extLst xmlns:a="http://schemas.openxmlformats.org/drawingml/2006/main">
               <a:ext uri="{FF2B5EF4-FFF2-40B4-BE49-F238E27FC236}">
-                <a16:creationId xmlns:a16="http://schemas.microsoft.com/office/drawing/2014/main" id="{09E7D02E-AC93-4FA1-A98E-700AC20C2BB1}"/>
+                <a16:creationId xmlns:a16="http://schemas.microsoft.com/office/drawing/2014/main" id="{D65B0619-82AE-4DF5-996E-6C94B0CD287D}"/>
               </a:ext>
             </a:extLst>
           </p:cNvPr>
@@ -5944,7 +5944,7 @@
           <p:cNvPr id="19" name="">
             <a:extLst xmlns:a="http://schemas.openxmlformats.org/drawingml/2006/main">
               <a:ext uri="{FF2B5EF4-FFF2-40B4-BE49-F238E27FC236}">
-                <a16:creationId xmlns:a16="http://schemas.microsoft.com/office/drawing/2014/main" id="{36EBDD07-F1D6-47C6-BD99-1E871BD7DCFB}"/>
+                <a16:creationId xmlns:a16="http://schemas.microsoft.com/office/drawing/2014/main" id="{B2004763-9FCB-4DD3-AE3A-E693ED2E0064}"/>
               </a:ext>
             </a:extLst>
           </p:cNvPr>
@@ -6002,7 +6002,7 @@
           <p:cNvPr id="20" name="">
             <a:extLst xmlns:a="http://schemas.openxmlformats.org/drawingml/2006/main">
               <a:ext uri="{FF2B5EF4-FFF2-40B4-BE49-F238E27FC236}">
-                <a16:creationId xmlns:a16="http://schemas.microsoft.com/office/drawing/2014/main" id="{594C8347-9A49-49A2-A018-7D40EA395282}"/>
+                <a16:creationId xmlns:a16="http://schemas.microsoft.com/office/drawing/2014/main" id="{33A0F3C1-B612-4E5A-90A5-90BB46562CE4}"/>
               </a:ext>
             </a:extLst>
           </p:cNvPr>
@@ -6058,7 +6058,7 @@
     </p:spTree>
     <p:extLst>
       <p:ext uri="{BB962C8B-B14F-4D97-AF65-F5344CB8AC3E}">
-        <p14:creationId xmlns:p14="http://schemas.microsoft.com/office/powerpoint/2010/main" val="1340187822"/>
+        <p14:creationId xmlns:p14="http://schemas.microsoft.com/office/powerpoint/2010/main" val="1658853641"/>
       </p:ext>
     </p:extLst>
   </p:cSld>
@@ -6089,7 +6089,7 @@
           <p:cNvPr id="14" name="">
             <a:extLst xmlns:a="http://schemas.openxmlformats.org/drawingml/2006/main">
               <a:ext uri="{FF2B5EF4-FFF2-40B4-BE49-F238E27FC236}">
-                <a16:creationId xmlns:a16="http://schemas.microsoft.com/office/drawing/2014/main" id="{9B5EF9E3-63BE-423B-87B6-EB67BFE32BF2}"/>
+                <a16:creationId xmlns:a16="http://schemas.microsoft.com/office/drawing/2014/main" id="{9620BE1E-30DE-48EA-A577-BAFC832DAF66}"/>
               </a:ext>
             </a:extLst>
           </p:cNvPr>
@@ -6147,7 +6147,7 @@
           <p:cNvPr id="2" name="">
             <a:extLst xmlns:a="http://schemas.openxmlformats.org/drawingml/2006/main">
               <a:ext uri="{FF2B5EF4-FFF2-40B4-BE49-F238E27FC236}">
-                <a16:creationId xmlns:a16="http://schemas.microsoft.com/office/drawing/2014/main" id="{6433DB58-DBCF-4D91-8577-8BC8449A97B4}"/>
+                <a16:creationId xmlns:a16="http://schemas.microsoft.com/office/drawing/2014/main" id="{79FC7D56-7E04-4ECE-9954-335E25AC5255}"/>
               </a:ext>
             </a:extLst>
           </p:cNvPr>
@@ -6205,7 +6205,7 @@
           <p:cNvPr id="3" name="">
             <a:extLst xmlns:a="http://schemas.openxmlformats.org/drawingml/2006/main">
               <a:ext uri="{FF2B5EF4-FFF2-40B4-BE49-F238E27FC236}">
-                <a16:creationId xmlns:a16="http://schemas.microsoft.com/office/drawing/2014/main" id="{68367DB4-E20E-4F47-ABA1-E7D9D63FF121}"/>
+                <a16:creationId xmlns:a16="http://schemas.microsoft.com/office/drawing/2014/main" id="{4CF79C1E-0BF7-4626-BB22-66B8C87D844E}"/>
               </a:ext>
             </a:extLst>
           </p:cNvPr>
@@ -6263,7 +6263,7 @@
           <p:cNvPr id="4" name="">
             <a:extLst xmlns:a="http://schemas.openxmlformats.org/drawingml/2006/main">
               <a:ext uri="{FF2B5EF4-FFF2-40B4-BE49-F238E27FC236}">
-                <a16:creationId xmlns:a16="http://schemas.microsoft.com/office/drawing/2014/main" id="{AF07C2E9-05B9-4EB2-9F9D-4CDA38ADE432}"/>
+                <a16:creationId xmlns:a16="http://schemas.microsoft.com/office/drawing/2014/main" id="{A66FFCCC-33DC-4FCF-BF31-6D9B2AB2E00F}"/>
               </a:ext>
             </a:extLst>
           </p:cNvPr>
@@ -6321,7 +6321,7 @@
           <p:cNvPr id="5" name="">
             <a:extLst xmlns:a="http://schemas.openxmlformats.org/drawingml/2006/main">
               <a:ext uri="{FF2B5EF4-FFF2-40B4-BE49-F238E27FC236}">
-                <a16:creationId xmlns:a16="http://schemas.microsoft.com/office/drawing/2014/main" id="{050F2AAB-FFB5-4C20-BBDB-7EF754CDB50D}"/>
+                <a16:creationId xmlns:a16="http://schemas.microsoft.com/office/drawing/2014/main" id="{59E81100-3C8B-4ABE-90C7-1944248730E2}"/>
               </a:ext>
             </a:extLst>
           </p:cNvPr>
@@ -6354,7 +6354,7 @@
           <p:cNvPr id="6" name="">
             <a:extLst xmlns:a="http://schemas.openxmlformats.org/drawingml/2006/main">
               <a:ext uri="{FF2B5EF4-FFF2-40B4-BE49-F238E27FC236}">
-                <a16:creationId xmlns:a16="http://schemas.microsoft.com/office/drawing/2014/main" id="{2EFF0654-B80C-4A45-BD93-2DE85818FB68}"/>
+                <a16:creationId xmlns:a16="http://schemas.microsoft.com/office/drawing/2014/main" id="{874E5E39-5D16-4ADC-BE00-952C8D93B066}"/>
               </a:ext>
             </a:extLst>
           </p:cNvPr>
@@ -6412,7 +6412,7 @@
           <p:cNvPr id="7" name="">
             <a:extLst xmlns:a="http://schemas.openxmlformats.org/drawingml/2006/main">
               <a:ext uri="{FF2B5EF4-FFF2-40B4-BE49-F238E27FC236}">
-                <a16:creationId xmlns:a16="http://schemas.microsoft.com/office/drawing/2014/main" id="{3BA1A03F-3F4C-4829-AC6E-1C1F572F99E8}"/>
+                <a16:creationId xmlns:a16="http://schemas.microsoft.com/office/drawing/2014/main" id="{AB4D27F1-71DC-4695-96B3-22381B253C41}"/>
               </a:ext>
             </a:extLst>
           </p:cNvPr>
@@ -6470,7 +6470,7 @@
           <p:cNvPr id="8" name="">
             <a:extLst xmlns:a="http://schemas.openxmlformats.org/drawingml/2006/main">
               <a:ext uri="{FF2B5EF4-FFF2-40B4-BE49-F238E27FC236}">
-                <a16:creationId xmlns:a16="http://schemas.microsoft.com/office/drawing/2014/main" id="{E4847E7D-0FB3-41CF-BAB9-A2573A375F28}"/>
+                <a16:creationId xmlns:a16="http://schemas.microsoft.com/office/drawing/2014/main" id="{382C50D5-16A4-407E-B1F6-1B2E14555508}"/>
               </a:ext>
             </a:extLst>
           </p:cNvPr>
@@ -6503,7 +6503,7 @@
           <p:cNvPr id="9" name="">
             <a:extLst xmlns:a="http://schemas.openxmlformats.org/drawingml/2006/main">
               <a:ext uri="{FF2B5EF4-FFF2-40B4-BE49-F238E27FC236}">
-                <a16:creationId xmlns:a16="http://schemas.microsoft.com/office/drawing/2014/main" id="{AD068252-BA08-4BE0-8134-2305C2E04A47}"/>
+                <a16:creationId xmlns:a16="http://schemas.microsoft.com/office/drawing/2014/main" id="{4B7C768B-237D-4DF4-9451-93B128C9ED23}"/>
               </a:ext>
             </a:extLst>
           </p:cNvPr>
@@ -6561,7 +6561,7 @@
           <p:cNvPr id="10" name="">
             <a:extLst xmlns:a="http://schemas.openxmlformats.org/drawingml/2006/main">
               <a:ext uri="{FF2B5EF4-FFF2-40B4-BE49-F238E27FC236}">
-                <a16:creationId xmlns:a16="http://schemas.microsoft.com/office/drawing/2014/main" id="{B41450B2-85A5-4B9C-8064-A8275B92D2DE}"/>
+                <a16:creationId xmlns:a16="http://schemas.microsoft.com/office/drawing/2014/main" id="{0E32B196-1239-4FAC-BDD3-FDA2223506CE}"/>
               </a:ext>
             </a:extLst>
           </p:cNvPr>
@@ -6619,7 +6619,7 @@
           <p:cNvPr id="11" name="">
             <a:extLst xmlns:a="http://schemas.openxmlformats.org/drawingml/2006/main">
               <a:ext uri="{FF2B5EF4-FFF2-40B4-BE49-F238E27FC236}">
-                <a16:creationId xmlns:a16="http://schemas.microsoft.com/office/drawing/2014/main" id="{236BF2E7-8634-4B6C-9EB1-B8C120E189EE}"/>
+                <a16:creationId xmlns:a16="http://schemas.microsoft.com/office/drawing/2014/main" id="{0C0BE674-2DDE-4F71-99E7-DC6733CFE142}"/>
               </a:ext>
             </a:extLst>
           </p:cNvPr>
@@ -6652,7 +6652,7 @@
           <p:cNvPr id="12" name="">
             <a:extLst xmlns:a="http://schemas.openxmlformats.org/drawingml/2006/main">
               <a:ext uri="{FF2B5EF4-FFF2-40B4-BE49-F238E27FC236}">
-                <a16:creationId xmlns:a16="http://schemas.microsoft.com/office/drawing/2014/main" id="{E1079C78-EC03-428A-AD26-C2AEE00FAA0D}"/>
+                <a16:creationId xmlns:a16="http://schemas.microsoft.com/office/drawing/2014/main" id="{F8CF4293-1E4F-428F-BC20-F85126D002BC}"/>
               </a:ext>
             </a:extLst>
           </p:cNvPr>
@@ -6710,7 +6710,7 @@
           <p:cNvPr id="13" name="">
             <a:extLst xmlns:a="http://schemas.openxmlformats.org/drawingml/2006/main">
               <a:ext uri="{FF2B5EF4-FFF2-40B4-BE49-F238E27FC236}">
-                <a16:creationId xmlns:a16="http://schemas.microsoft.com/office/drawing/2014/main" id="{3EFC4150-02DF-4DAC-BF58-95EFDA7A2975}"/>
+                <a16:creationId xmlns:a16="http://schemas.microsoft.com/office/drawing/2014/main" id="{62EDE19B-EA0E-4956-83A6-57EE33A68CB9}"/>
               </a:ext>
             </a:extLst>
           </p:cNvPr>
@@ -6766,7 +6766,7 @@
     </p:spTree>
     <p:extLst>
       <p:ext uri="{BB962C8B-B14F-4D97-AF65-F5344CB8AC3E}">
-        <p14:creationId xmlns:p14="http://schemas.microsoft.com/office/powerpoint/2010/main" val="1250407857"/>
+        <p14:creationId xmlns:p14="http://schemas.microsoft.com/office/powerpoint/2010/main" val="1208393412"/>
       </p:ext>
     </p:extLst>
   </p:cSld>
@@ -6797,7 +6797,7 @@
           <p:cNvPr id="14" name="">
             <a:extLst xmlns:a="http://schemas.openxmlformats.org/drawingml/2006/main">
               <a:ext uri="{FF2B5EF4-FFF2-40B4-BE49-F238E27FC236}">
-                <a16:creationId xmlns:a16="http://schemas.microsoft.com/office/drawing/2014/main" id="{B3A55F64-EF84-420A-A5D4-99910427EA7A}"/>
+                <a16:creationId xmlns:a16="http://schemas.microsoft.com/office/drawing/2014/main" id="{E8AA4392-5933-4329-9575-B493C746BD16}"/>
               </a:ext>
             </a:extLst>
           </p:cNvPr>
@@ -6855,7 +6855,7 @@
           <p:cNvPr id="2" name="">
             <a:extLst xmlns:a="http://schemas.openxmlformats.org/drawingml/2006/main">
               <a:ext uri="{FF2B5EF4-FFF2-40B4-BE49-F238E27FC236}">
-                <a16:creationId xmlns:a16="http://schemas.microsoft.com/office/drawing/2014/main" id="{88CCC557-2F97-4B74-A08D-BA5980BB2FA1}"/>
+                <a16:creationId xmlns:a16="http://schemas.microsoft.com/office/drawing/2014/main" id="{6860E18A-9A83-4E23-948E-1498631AE095}"/>
               </a:ext>
             </a:extLst>
           </p:cNvPr>
@@ -6913,7 +6913,7 @@
           <p:cNvPr id="3" name="">
             <a:extLst xmlns:a="http://schemas.openxmlformats.org/drawingml/2006/main">
               <a:ext uri="{FF2B5EF4-FFF2-40B4-BE49-F238E27FC236}">
-                <a16:creationId xmlns:a16="http://schemas.microsoft.com/office/drawing/2014/main" id="{C2E46F03-EC25-42D6-BCBD-AB66E7535E40}"/>
+                <a16:creationId xmlns:a16="http://schemas.microsoft.com/office/drawing/2014/main" id="{F62DBD99-439B-421F-943D-C01061771FDC}"/>
               </a:ext>
             </a:extLst>
           </p:cNvPr>
@@ -6971,7 +6971,7 @@
           <p:cNvPr id="4" name="">
             <a:extLst xmlns:a="http://schemas.openxmlformats.org/drawingml/2006/main">
               <a:ext uri="{FF2B5EF4-FFF2-40B4-BE49-F238E27FC236}">
-                <a16:creationId xmlns:a16="http://schemas.microsoft.com/office/drawing/2014/main" id="{3C9640B2-539E-4F9E-8C3E-046EDED3A11B}"/>
+                <a16:creationId xmlns:a16="http://schemas.microsoft.com/office/drawing/2014/main" id="{592E456E-E0CA-42D9-AA80-E13608C6D961}"/>
               </a:ext>
             </a:extLst>
           </p:cNvPr>
@@ -7033,20 +7033,20 @@
           <p:nvPr/>
         </p:nvPicPr>
         <p:blipFill>
-          <a:blip xmlns:r="http://schemas.openxmlformats.org/officeDocument/2006/relationships" xmlns:a="http://schemas.openxmlformats.org/drawingml/2006/main" r:embed="Rce6a2fc52b294770"/>
-          <a:srcRect xmlns:a="http://schemas.openxmlformats.org/drawingml/2006/main" l="3401" t="0" r="3401" b="0"/>
+          <a:blip xmlns:r="http://schemas.openxmlformats.org/officeDocument/2006/relationships" xmlns:a="http://schemas.openxmlformats.org/drawingml/2006/main" r:embed="Rda43d2918076475f"/>
+          <a:srcRect xmlns:a="http://schemas.openxmlformats.org/drawingml/2006/main" l="0" t="0" r="0" b="0"/>
           <a:stretch xmlns:a="http://schemas.openxmlformats.org/drawingml/2006/main">
             <a:fillRect l="0" t="0" r="0" b="0"/>
           </a:stretch>
         </p:blipFill>
         <p:spPr>
           <a:xfrm xmlns:a="http://schemas.openxmlformats.org/drawingml/2006/main">
-            <a:off x="6572250" y="400050"/>
-            <a:ext cx="5219700" cy="5600700"/>
+            <a:off x="7048500" y="1257300"/>
+            <a:ext cx="4743450" cy="4743450"/>
           </a:xfrm>
           <a:prstGeom xmlns:a="http://schemas.openxmlformats.org/drawingml/2006/main" prst="roundRect">
             <a:avLst>
-              <a:gd name="adj" fmla="val 2190"/>
+              <a:gd name="adj" fmla="val 2410"/>
             </a:avLst>
           </a:prstGeom>
         </p:spPr>
@@ -7056,7 +7056,7 @@
           <p:cNvPr id="6" name="">
             <a:extLst xmlns:a="http://schemas.openxmlformats.org/drawingml/2006/main">
               <a:ext uri="{FF2B5EF4-FFF2-40B4-BE49-F238E27FC236}">
-                <a16:creationId xmlns:a16="http://schemas.microsoft.com/office/drawing/2014/main" id="{9BBBDA87-660B-4499-AA54-8F9A870B10E0}"/>
+                <a16:creationId xmlns:a16="http://schemas.microsoft.com/office/drawing/2014/main" id="{54797821-7FB3-4767-8990-C5A06B557D0C}"/>
               </a:ext>
             </a:extLst>
           </p:cNvPr>
@@ -7089,7 +7089,7 @@
           <p:cNvPr id="7" name="">
             <a:extLst xmlns:a="http://schemas.openxmlformats.org/drawingml/2006/main">
               <a:ext uri="{FF2B5EF4-FFF2-40B4-BE49-F238E27FC236}">
-                <a16:creationId xmlns:a16="http://schemas.microsoft.com/office/drawing/2014/main" id="{20AD76BE-BA11-42A0-8E0E-0F3C21DB001E}"/>
+                <a16:creationId xmlns:a16="http://schemas.microsoft.com/office/drawing/2014/main" id="{CD2D71E4-BB5F-4981-9E8B-A139B0E0986B}"/>
               </a:ext>
             </a:extLst>
           </p:cNvPr>
@@ -7147,7 +7147,7 @@
           <p:cNvPr id="8" name="">
             <a:extLst xmlns:a="http://schemas.openxmlformats.org/drawingml/2006/main">
               <a:ext uri="{FF2B5EF4-FFF2-40B4-BE49-F238E27FC236}">
-                <a16:creationId xmlns:a16="http://schemas.microsoft.com/office/drawing/2014/main" id="{AE416674-8D50-4D37-8BDB-FE1FFB1BBFF3}"/>
+                <a16:creationId xmlns:a16="http://schemas.microsoft.com/office/drawing/2014/main" id="{31871949-72FE-4199-A569-34524CE6773E}"/>
               </a:ext>
             </a:extLst>
           </p:cNvPr>
@@ -7205,7 +7205,7 @@
           <p:cNvPr id="9" name="">
             <a:extLst xmlns:a="http://schemas.openxmlformats.org/drawingml/2006/main">
               <a:ext uri="{FF2B5EF4-FFF2-40B4-BE49-F238E27FC236}">
-                <a16:creationId xmlns:a16="http://schemas.microsoft.com/office/drawing/2014/main" id="{ACF2CAB6-E7F7-45C8-B3EC-D57F9BD35EF0}"/>
+                <a16:creationId xmlns:a16="http://schemas.microsoft.com/office/drawing/2014/main" id="{AE513E3B-07D5-4850-8C11-EB0FEB4CF425}"/>
               </a:ext>
             </a:extLst>
           </p:cNvPr>
@@ -7263,7 +7263,7 @@
           <p:cNvPr id="10" name="">
             <a:extLst xmlns:a="http://schemas.openxmlformats.org/drawingml/2006/main">
               <a:ext uri="{FF2B5EF4-FFF2-40B4-BE49-F238E27FC236}">
-                <a16:creationId xmlns:a16="http://schemas.microsoft.com/office/drawing/2014/main" id="{24027178-D405-41C2-A36C-B92BB4A6D473}"/>
+                <a16:creationId xmlns:a16="http://schemas.microsoft.com/office/drawing/2014/main" id="{F1922798-8D5B-44FC-8408-904CA51375FC}"/>
               </a:ext>
             </a:extLst>
           </p:cNvPr>
@@ -7296,7 +7296,7 @@
           <p:cNvPr id="11" name="">
             <a:extLst xmlns:a="http://schemas.openxmlformats.org/drawingml/2006/main">
               <a:ext uri="{FF2B5EF4-FFF2-40B4-BE49-F238E27FC236}">
-                <a16:creationId xmlns:a16="http://schemas.microsoft.com/office/drawing/2014/main" id="{45E25D4F-115A-4E03-B1BE-00E4B9098863}"/>
+                <a16:creationId xmlns:a16="http://schemas.microsoft.com/office/drawing/2014/main" id="{A337397B-1A6C-4263-B774-AF4BA8CD98B7}"/>
               </a:ext>
             </a:extLst>
           </p:cNvPr>
@@ -7354,7 +7354,7 @@
           <p:cNvPr id="12" name="">
             <a:extLst xmlns:a="http://schemas.openxmlformats.org/drawingml/2006/main">
               <a:ext uri="{FF2B5EF4-FFF2-40B4-BE49-F238E27FC236}">
-                <a16:creationId xmlns:a16="http://schemas.microsoft.com/office/drawing/2014/main" id="{9FA3FB33-7585-4DE8-9019-B9F11C784C65}"/>
+                <a16:creationId xmlns:a16="http://schemas.microsoft.com/office/drawing/2014/main" id="{158AD9AA-2781-431E-A1FC-4ED6082D0BBD}"/>
               </a:ext>
             </a:extLst>
           </p:cNvPr>
@@ -7412,7 +7412,7 @@
           <p:cNvPr id="13" name="">
             <a:extLst xmlns:a="http://schemas.openxmlformats.org/drawingml/2006/main">
               <a:ext uri="{FF2B5EF4-FFF2-40B4-BE49-F238E27FC236}">
-                <a16:creationId xmlns:a16="http://schemas.microsoft.com/office/drawing/2014/main" id="{313BDE89-1865-45EA-AEFA-6AFB830850D3}"/>
+                <a16:creationId xmlns:a16="http://schemas.microsoft.com/office/drawing/2014/main" id="{107F9760-8E06-461F-8A6F-8E69FFB3BFAC}"/>
               </a:ext>
             </a:extLst>
           </p:cNvPr>
@@ -7468,7 +7468,7 @@
     </p:spTree>
     <p:extLst>
       <p:ext uri="{BB962C8B-B14F-4D97-AF65-F5344CB8AC3E}">
-        <p14:creationId xmlns:p14="http://schemas.microsoft.com/office/powerpoint/2010/main" val="1675954892"/>
+        <p14:creationId xmlns:p14="http://schemas.microsoft.com/office/powerpoint/2010/main" val="541760789"/>
       </p:ext>
     </p:extLst>
   </p:cSld>
@@ -7499,7 +7499,7 @@
           <p:cNvPr id="23" name="">
             <a:extLst xmlns:a="http://schemas.openxmlformats.org/drawingml/2006/main">
               <a:ext uri="{FF2B5EF4-FFF2-40B4-BE49-F238E27FC236}">
-                <a16:creationId xmlns:a16="http://schemas.microsoft.com/office/drawing/2014/main" id="{2F5CC20C-0724-427D-AE77-23DE580340A4}"/>
+                <a16:creationId xmlns:a16="http://schemas.microsoft.com/office/drawing/2014/main" id="{30B6BB64-11E8-4BE1-AAB1-C63F605CE400}"/>
               </a:ext>
             </a:extLst>
           </p:cNvPr>
@@ -7557,7 +7557,7 @@
           <p:cNvPr id="2" name="">
             <a:extLst xmlns:a="http://schemas.openxmlformats.org/drawingml/2006/main">
               <a:ext uri="{FF2B5EF4-FFF2-40B4-BE49-F238E27FC236}">
-                <a16:creationId xmlns:a16="http://schemas.microsoft.com/office/drawing/2014/main" id="{3836E622-9B25-404D-B028-088CDA300D03}"/>
+                <a16:creationId xmlns:a16="http://schemas.microsoft.com/office/drawing/2014/main" id="{E9EF677C-A4A0-47DF-BC76-96CB00A383CA}"/>
               </a:ext>
             </a:extLst>
           </p:cNvPr>
@@ -7615,7 +7615,7 @@
           <p:cNvPr id="3" name="">
             <a:extLst xmlns:a="http://schemas.openxmlformats.org/drawingml/2006/main">
               <a:ext uri="{FF2B5EF4-FFF2-40B4-BE49-F238E27FC236}">
-                <a16:creationId xmlns:a16="http://schemas.microsoft.com/office/drawing/2014/main" id="{FC5C27DB-159A-4FB0-B788-4FA06AE15296}"/>
+                <a16:creationId xmlns:a16="http://schemas.microsoft.com/office/drawing/2014/main" id="{AB764A9F-1B9F-4D6E-92ED-DED479F02DE2}"/>
               </a:ext>
             </a:extLst>
           </p:cNvPr>
@@ -7673,7 +7673,7 @@
           <p:cNvPr id="4" name="">
             <a:extLst xmlns:a="http://schemas.openxmlformats.org/drawingml/2006/main">
               <a:ext uri="{FF2B5EF4-FFF2-40B4-BE49-F238E27FC236}">
-                <a16:creationId xmlns:a16="http://schemas.microsoft.com/office/drawing/2014/main" id="{1A274108-21AA-4FF4-80CE-0935264E949B}"/>
+                <a16:creationId xmlns:a16="http://schemas.microsoft.com/office/drawing/2014/main" id="{02EFC2AD-3BF0-464B-A073-8A0159EE1B76}"/>
               </a:ext>
             </a:extLst>
           </p:cNvPr>
@@ -7731,7 +7731,7 @@
           <p:cNvPr id="5" name="">
             <a:extLst xmlns:a="http://schemas.openxmlformats.org/drawingml/2006/main">
               <a:ext uri="{FF2B5EF4-FFF2-40B4-BE49-F238E27FC236}">
-                <a16:creationId xmlns:a16="http://schemas.microsoft.com/office/drawing/2014/main" id="{1D163E41-F799-4314-AA44-458B6106FAA3}"/>
+                <a16:creationId xmlns:a16="http://schemas.microsoft.com/office/drawing/2014/main" id="{8DBBBF33-1E5B-4E3B-A53C-ABE26EC62B9F}"/>
               </a:ext>
             </a:extLst>
           </p:cNvPr>
@@ -7764,7 +7764,7 @@
           <p:cNvPr id="6" name="">
             <a:extLst xmlns:a="http://schemas.openxmlformats.org/drawingml/2006/main">
               <a:ext uri="{FF2B5EF4-FFF2-40B4-BE49-F238E27FC236}">
-                <a16:creationId xmlns:a16="http://schemas.microsoft.com/office/drawing/2014/main" id="{02D22B24-F121-49FA-BD5A-492641FA13A6}"/>
+                <a16:creationId xmlns:a16="http://schemas.microsoft.com/office/drawing/2014/main" id="{5280C503-6EDC-4155-8F3A-FB91207DF24C}"/>
               </a:ext>
             </a:extLst>
           </p:cNvPr>
@@ -7822,7 +7822,7 @@
           <p:cNvPr id="7" name="">
             <a:extLst xmlns:a="http://schemas.openxmlformats.org/drawingml/2006/main">
               <a:ext uri="{FF2B5EF4-FFF2-40B4-BE49-F238E27FC236}">
-                <a16:creationId xmlns:a16="http://schemas.microsoft.com/office/drawing/2014/main" id="{8DA8A59B-4AA1-47AA-A7BE-36195247AF25}"/>
+                <a16:creationId xmlns:a16="http://schemas.microsoft.com/office/drawing/2014/main" id="{DFEF1DCB-8A77-4AE0-9CEB-7F13386D1D42}"/>
               </a:ext>
             </a:extLst>
           </p:cNvPr>
@@ -7880,7 +7880,7 @@
           <p:cNvPr id="8" name="">
             <a:extLst xmlns:a="http://schemas.openxmlformats.org/drawingml/2006/main">
               <a:ext uri="{FF2B5EF4-FFF2-40B4-BE49-F238E27FC236}">
-                <a16:creationId xmlns:a16="http://schemas.microsoft.com/office/drawing/2014/main" id="{FA366140-697E-48AF-9826-7366DD3287DF}"/>
+                <a16:creationId xmlns:a16="http://schemas.microsoft.com/office/drawing/2014/main" id="{BDA84DA3-E8CF-4DE3-9B07-4C88121EF29D}"/>
               </a:ext>
             </a:extLst>
           </p:cNvPr>
@@ -7911,7 +7911,7 @@
           <p:cNvPr id="9" name="">
             <a:extLst xmlns:a="http://schemas.openxmlformats.org/drawingml/2006/main">
               <a:ext uri="{FF2B5EF4-FFF2-40B4-BE49-F238E27FC236}">
-                <a16:creationId xmlns:a16="http://schemas.microsoft.com/office/drawing/2014/main" id="{AF47FADF-0081-4FDD-BEE6-C260406629BF}"/>
+                <a16:creationId xmlns:a16="http://schemas.microsoft.com/office/drawing/2014/main" id="{903DB0A2-E654-4620-ACC2-7B0C0AACA61B}"/>
               </a:ext>
             </a:extLst>
           </p:cNvPr>
@@ -7969,7 +7969,7 @@
           <p:cNvPr id="10" name="">
             <a:extLst xmlns:a="http://schemas.openxmlformats.org/drawingml/2006/main">
               <a:ext uri="{FF2B5EF4-FFF2-40B4-BE49-F238E27FC236}">
-                <a16:creationId xmlns:a16="http://schemas.microsoft.com/office/drawing/2014/main" id="{4F6C63B3-A3A1-4994-9FD0-1053D2C185E9}"/>
+                <a16:creationId xmlns:a16="http://schemas.microsoft.com/office/drawing/2014/main" id="{39CD4918-1ADD-4E9F-81FF-4553E91835B7}"/>
               </a:ext>
             </a:extLst>
           </p:cNvPr>
@@ -8002,7 +8002,7 @@
           <p:cNvPr id="11" name="">
             <a:extLst xmlns:a="http://schemas.openxmlformats.org/drawingml/2006/main">
               <a:ext uri="{FF2B5EF4-FFF2-40B4-BE49-F238E27FC236}">
-                <a16:creationId xmlns:a16="http://schemas.microsoft.com/office/drawing/2014/main" id="{4F537366-41D2-4FF8-AE37-2B39CD287BFE}"/>
+                <a16:creationId xmlns:a16="http://schemas.microsoft.com/office/drawing/2014/main" id="{3EFC873F-1DB0-49CA-848F-CDD7481C65C9}"/>
               </a:ext>
             </a:extLst>
           </p:cNvPr>
@@ -8060,7 +8060,7 @@
           <p:cNvPr id="12" name="">
             <a:extLst xmlns:a="http://schemas.openxmlformats.org/drawingml/2006/main">
               <a:ext uri="{FF2B5EF4-FFF2-40B4-BE49-F238E27FC236}">
-                <a16:creationId xmlns:a16="http://schemas.microsoft.com/office/drawing/2014/main" id="{4F4FA5D0-2378-4A09-A4F0-D66CCC5EBD01}"/>
+                <a16:creationId xmlns:a16="http://schemas.microsoft.com/office/drawing/2014/main" id="{F8777E08-B73A-4CB3-9C2E-E05D4BAEA7BB}"/>
               </a:ext>
             </a:extLst>
           </p:cNvPr>
@@ -8118,7 +8118,7 @@
           <p:cNvPr id="13" name="">
             <a:extLst xmlns:a="http://schemas.openxmlformats.org/drawingml/2006/main">
               <a:ext uri="{FF2B5EF4-FFF2-40B4-BE49-F238E27FC236}">
-                <a16:creationId xmlns:a16="http://schemas.microsoft.com/office/drawing/2014/main" id="{80AC12D0-0725-480F-A39B-E54E8C9C1ECD}"/>
+                <a16:creationId xmlns:a16="http://schemas.microsoft.com/office/drawing/2014/main" id="{BE578B48-4E12-473A-8AD8-3F973B7DA44A}"/>
               </a:ext>
             </a:extLst>
           </p:cNvPr>
@@ -8149,7 +8149,7 @@
           <p:cNvPr id="14" name="">
             <a:extLst xmlns:a="http://schemas.openxmlformats.org/drawingml/2006/main">
               <a:ext uri="{FF2B5EF4-FFF2-40B4-BE49-F238E27FC236}">
-                <a16:creationId xmlns:a16="http://schemas.microsoft.com/office/drawing/2014/main" id="{61BE0D08-7EE4-4474-8740-F401D3DC6834}"/>
+                <a16:creationId xmlns:a16="http://schemas.microsoft.com/office/drawing/2014/main" id="{2CF2872E-7FB5-4948-AB94-7A855B337801}"/>
               </a:ext>
             </a:extLst>
           </p:cNvPr>
@@ -8207,7 +8207,7 @@
           <p:cNvPr id="15" name="">
             <a:extLst xmlns:a="http://schemas.openxmlformats.org/drawingml/2006/main">
               <a:ext uri="{FF2B5EF4-FFF2-40B4-BE49-F238E27FC236}">
-                <a16:creationId xmlns:a16="http://schemas.microsoft.com/office/drawing/2014/main" id="{BA60C5BD-E738-462D-9249-CA4AD8732FEC}"/>
+                <a16:creationId xmlns:a16="http://schemas.microsoft.com/office/drawing/2014/main" id="{0EC5AB8F-3FEB-49F4-916F-5FB9B9D908B5}"/>
               </a:ext>
             </a:extLst>
           </p:cNvPr>
@@ -8240,7 +8240,7 @@
           <p:cNvPr id="16" name="">
             <a:extLst xmlns:a="http://schemas.openxmlformats.org/drawingml/2006/main">
               <a:ext uri="{FF2B5EF4-FFF2-40B4-BE49-F238E27FC236}">
-                <a16:creationId xmlns:a16="http://schemas.microsoft.com/office/drawing/2014/main" id="{CA9E4FC4-CBA3-4A66-AF9A-A3132243182C}"/>
+                <a16:creationId xmlns:a16="http://schemas.microsoft.com/office/drawing/2014/main" id="{C09710FD-0942-47B4-9368-BEF4718AABDC}"/>
               </a:ext>
             </a:extLst>
           </p:cNvPr>
@@ -8298,7 +8298,7 @@
           <p:cNvPr id="17" name="">
             <a:extLst xmlns:a="http://schemas.openxmlformats.org/drawingml/2006/main">
               <a:ext uri="{FF2B5EF4-FFF2-40B4-BE49-F238E27FC236}">
-                <a16:creationId xmlns:a16="http://schemas.microsoft.com/office/drawing/2014/main" id="{4EEE35CA-4BDE-4E0B-AFD2-BD17CF550291}"/>
+                <a16:creationId xmlns:a16="http://schemas.microsoft.com/office/drawing/2014/main" id="{6DDDA723-658E-4407-AF44-1B659DD6F35F}"/>
               </a:ext>
             </a:extLst>
           </p:cNvPr>
@@ -8356,7 +8356,7 @@
           <p:cNvPr id="18" name="">
             <a:extLst xmlns:a="http://schemas.openxmlformats.org/drawingml/2006/main">
               <a:ext uri="{FF2B5EF4-FFF2-40B4-BE49-F238E27FC236}">
-                <a16:creationId xmlns:a16="http://schemas.microsoft.com/office/drawing/2014/main" id="{9429808E-24FB-49BE-8378-DDCD2891902E}"/>
+                <a16:creationId xmlns:a16="http://schemas.microsoft.com/office/drawing/2014/main" id="{EADD2D64-E00C-4958-9A32-C13681BE0F58}"/>
               </a:ext>
             </a:extLst>
           </p:cNvPr>
@@ -8387,7 +8387,7 @@
           <p:cNvPr id="19" name="">
             <a:extLst xmlns:a="http://schemas.openxmlformats.org/drawingml/2006/main">
               <a:ext uri="{FF2B5EF4-FFF2-40B4-BE49-F238E27FC236}">
-                <a16:creationId xmlns:a16="http://schemas.microsoft.com/office/drawing/2014/main" id="{E32AEC7A-1FF0-49C2-937D-02A98F04E7E7}"/>
+                <a16:creationId xmlns:a16="http://schemas.microsoft.com/office/drawing/2014/main" id="{254E0260-CBE3-4B3C-908C-A9D56A12D9F8}"/>
               </a:ext>
             </a:extLst>
           </p:cNvPr>
@@ -8445,7 +8445,7 @@
           <p:cNvPr id="20" name="">
             <a:extLst xmlns:a="http://schemas.openxmlformats.org/drawingml/2006/main">
               <a:ext uri="{FF2B5EF4-FFF2-40B4-BE49-F238E27FC236}">
-                <a16:creationId xmlns:a16="http://schemas.microsoft.com/office/drawing/2014/main" id="{7107151C-969D-4639-A439-3C094187BAB8}"/>
+                <a16:creationId xmlns:a16="http://schemas.microsoft.com/office/drawing/2014/main" id="{FF714CCE-82A3-4107-A405-C98C11118D3A}"/>
               </a:ext>
             </a:extLst>
           </p:cNvPr>
@@ -8478,7 +8478,7 @@
           <p:cNvPr id="21" name="">
             <a:extLst xmlns:a="http://schemas.openxmlformats.org/drawingml/2006/main">
               <a:ext uri="{FF2B5EF4-FFF2-40B4-BE49-F238E27FC236}">
-                <a16:creationId xmlns:a16="http://schemas.microsoft.com/office/drawing/2014/main" id="{CA09AE65-8819-4BD9-A777-A711E25AB26D}"/>
+                <a16:creationId xmlns:a16="http://schemas.microsoft.com/office/drawing/2014/main" id="{1D834EFE-B926-46A7-957C-1B48F54B8CBC}"/>
               </a:ext>
             </a:extLst>
           </p:cNvPr>
@@ -8536,7 +8536,7 @@
           <p:cNvPr id="22" name="">
             <a:extLst xmlns:a="http://schemas.openxmlformats.org/drawingml/2006/main">
               <a:ext uri="{FF2B5EF4-FFF2-40B4-BE49-F238E27FC236}">
-                <a16:creationId xmlns:a16="http://schemas.microsoft.com/office/drawing/2014/main" id="{C0470E19-1885-4125-8B2E-D0CECCE65235}"/>
+                <a16:creationId xmlns:a16="http://schemas.microsoft.com/office/drawing/2014/main" id="{680C5A13-ED86-4C29-BF5A-020B0165394F}"/>
               </a:ext>
             </a:extLst>
           </p:cNvPr>
@@ -8592,7 +8592,7 @@
     </p:spTree>
     <p:extLst>
       <p:ext uri="{BB962C8B-B14F-4D97-AF65-F5344CB8AC3E}">
-        <p14:creationId xmlns:p14="http://schemas.microsoft.com/office/powerpoint/2010/main" val="1132928981"/>
+        <p14:creationId xmlns:p14="http://schemas.microsoft.com/office/powerpoint/2010/main" val="1994500412"/>
       </p:ext>
     </p:extLst>
   </p:cSld>
@@ -8623,7 +8623,7 @@
           <p:cNvPr id="19" name="">
             <a:extLst xmlns:a="http://schemas.openxmlformats.org/drawingml/2006/main">
               <a:ext uri="{FF2B5EF4-FFF2-40B4-BE49-F238E27FC236}">
-                <a16:creationId xmlns:a16="http://schemas.microsoft.com/office/drawing/2014/main" id="{F5C07831-766E-4516-804E-1E8BA1275205}"/>
+                <a16:creationId xmlns:a16="http://schemas.microsoft.com/office/drawing/2014/main" id="{11217681-242C-42A7-A9AA-C170FA2FB347}"/>
               </a:ext>
             </a:extLst>
           </p:cNvPr>
@@ -8681,7 +8681,7 @@
           <p:cNvPr id="2" name="">
             <a:extLst xmlns:a="http://schemas.openxmlformats.org/drawingml/2006/main">
               <a:ext uri="{FF2B5EF4-FFF2-40B4-BE49-F238E27FC236}">
-                <a16:creationId xmlns:a16="http://schemas.microsoft.com/office/drawing/2014/main" id="{1E68DF8C-4A39-41C0-AF25-70F95ED498B4}"/>
+                <a16:creationId xmlns:a16="http://schemas.microsoft.com/office/drawing/2014/main" id="{77540B55-918F-4F43-AE12-DED0DCA36B3F}"/>
               </a:ext>
             </a:extLst>
           </p:cNvPr>
@@ -8739,7 +8739,7 @@
           <p:cNvPr id="3" name="">
             <a:extLst xmlns:a="http://schemas.openxmlformats.org/drawingml/2006/main">
               <a:ext uri="{FF2B5EF4-FFF2-40B4-BE49-F238E27FC236}">
-                <a16:creationId xmlns:a16="http://schemas.microsoft.com/office/drawing/2014/main" id="{8111954D-C32F-4344-8ECF-87259C3E255F}"/>
+                <a16:creationId xmlns:a16="http://schemas.microsoft.com/office/drawing/2014/main" id="{BCBBED3D-FEC6-4C01-86B0-F6AE93156A05}"/>
               </a:ext>
             </a:extLst>
           </p:cNvPr>
@@ -8797,7 +8797,7 @@
           <p:cNvPr id="4" name="">
             <a:extLst xmlns:a="http://schemas.openxmlformats.org/drawingml/2006/main">
               <a:ext uri="{FF2B5EF4-FFF2-40B4-BE49-F238E27FC236}">
-                <a16:creationId xmlns:a16="http://schemas.microsoft.com/office/drawing/2014/main" id="{AB85686C-3EF1-4A82-8EDA-A3A213AD7EA4}"/>
+                <a16:creationId xmlns:a16="http://schemas.microsoft.com/office/drawing/2014/main" id="{2B45D39F-E2EF-4030-9BC6-0B454F8ADDCB}"/>
               </a:ext>
             </a:extLst>
           </p:cNvPr>
@@ -8859,7 +8859,7 @@
           <p:nvPr/>
         </p:nvPicPr>
         <p:blipFill>
-          <a:blip xmlns:r="http://schemas.openxmlformats.org/officeDocument/2006/relationships" xmlns:a="http://schemas.openxmlformats.org/drawingml/2006/main" r:embed="R383cc1dcff814290"/>
+          <a:blip xmlns:r="http://schemas.openxmlformats.org/officeDocument/2006/relationships" xmlns:a="http://schemas.openxmlformats.org/drawingml/2006/main" r:embed="R8c792faae15b4f4b"/>
           <a:srcRect xmlns:a="http://schemas.openxmlformats.org/drawingml/2006/main" l="11588" t="0" r="11588" b="0"/>
           <a:stretch xmlns:a="http://schemas.openxmlformats.org/drawingml/2006/main">
             <a:fillRect l="0" t="0" r="0" b="0"/>
@@ -8882,7 +8882,7 @@
           <p:cNvPr id="6" name="">
             <a:extLst xmlns:a="http://schemas.openxmlformats.org/drawingml/2006/main">
               <a:ext uri="{FF2B5EF4-FFF2-40B4-BE49-F238E27FC236}">
-                <a16:creationId xmlns:a16="http://schemas.microsoft.com/office/drawing/2014/main" id="{B81EFA69-9B4A-48C3-B22C-A5DB46B1EC69}"/>
+                <a16:creationId xmlns:a16="http://schemas.microsoft.com/office/drawing/2014/main" id="{2379F822-A412-4427-B35E-B270DE784322}"/>
               </a:ext>
             </a:extLst>
           </p:cNvPr>
@@ -8915,7 +8915,7 @@
           <p:cNvPr id="7" name="">
             <a:extLst xmlns:a="http://schemas.openxmlformats.org/drawingml/2006/main">
               <a:ext uri="{FF2B5EF4-FFF2-40B4-BE49-F238E27FC236}">
-                <a16:creationId xmlns:a16="http://schemas.microsoft.com/office/drawing/2014/main" id="{9254DE15-9FCF-46CA-BFB9-3737AFD60EC0}"/>
+                <a16:creationId xmlns:a16="http://schemas.microsoft.com/office/drawing/2014/main" id="{66F07ACB-EE7C-4595-8E2C-00919F982932}"/>
               </a:ext>
             </a:extLst>
           </p:cNvPr>
@@ -8973,7 +8973,7 @@
           <p:cNvPr id="8" name="">
             <a:extLst xmlns:a="http://schemas.openxmlformats.org/drawingml/2006/main">
               <a:ext uri="{FF2B5EF4-FFF2-40B4-BE49-F238E27FC236}">
-                <a16:creationId xmlns:a16="http://schemas.microsoft.com/office/drawing/2014/main" id="{75A6EF3B-62A2-4ADA-89E6-6139031E3154}"/>
+                <a16:creationId xmlns:a16="http://schemas.microsoft.com/office/drawing/2014/main" id="{5E02CE86-55B2-49BB-8DDF-DFEB027E7BCF}"/>
               </a:ext>
             </a:extLst>
           </p:cNvPr>
@@ -9031,7 +9031,7 @@
           <p:cNvPr id="9" name="">
             <a:extLst xmlns:a="http://schemas.openxmlformats.org/drawingml/2006/main">
               <a:ext uri="{FF2B5EF4-FFF2-40B4-BE49-F238E27FC236}">
-                <a16:creationId xmlns:a16="http://schemas.microsoft.com/office/drawing/2014/main" id="{ABB49593-6043-4C39-9CDE-A2D2AE76A0C4}"/>
+                <a16:creationId xmlns:a16="http://schemas.microsoft.com/office/drawing/2014/main" id="{40154740-AB99-4C0C-B5C1-D56D945D3DD9}"/>
               </a:ext>
             </a:extLst>
           </p:cNvPr>
@@ -9089,7 +9089,7 @@
           <p:cNvPr id="10" name="">
             <a:extLst xmlns:a="http://schemas.openxmlformats.org/drawingml/2006/main">
               <a:ext uri="{FF2B5EF4-FFF2-40B4-BE49-F238E27FC236}">
-                <a16:creationId xmlns:a16="http://schemas.microsoft.com/office/drawing/2014/main" id="{4A5E4B95-A653-4D27-A7DA-37D71B9F7B0D}"/>
+                <a16:creationId xmlns:a16="http://schemas.microsoft.com/office/drawing/2014/main" id="{ED050E5C-8851-46A9-9431-03D90AF548D9}"/>
               </a:ext>
             </a:extLst>
           </p:cNvPr>
@@ -9122,7 +9122,7 @@
           <p:cNvPr id="11" name="">
             <a:extLst xmlns:a="http://schemas.openxmlformats.org/drawingml/2006/main">
               <a:ext uri="{FF2B5EF4-FFF2-40B4-BE49-F238E27FC236}">
-                <a16:creationId xmlns:a16="http://schemas.microsoft.com/office/drawing/2014/main" id="{A0A40F37-C1E9-47D8-8D1D-E9AFBFE56F03}"/>
+                <a16:creationId xmlns:a16="http://schemas.microsoft.com/office/drawing/2014/main" id="{89AE6B4E-3789-4EB6-96A6-224D35135219}"/>
               </a:ext>
             </a:extLst>
           </p:cNvPr>
@@ -9180,7 +9180,7 @@
           <p:cNvPr id="12" name="">
             <a:extLst xmlns:a="http://schemas.openxmlformats.org/drawingml/2006/main">
               <a:ext uri="{FF2B5EF4-FFF2-40B4-BE49-F238E27FC236}">
-                <a16:creationId xmlns:a16="http://schemas.microsoft.com/office/drawing/2014/main" id="{0CC6F8DA-75DF-478B-A864-7B1EF8E2D6B3}"/>
+                <a16:creationId xmlns:a16="http://schemas.microsoft.com/office/drawing/2014/main" id="{6B554CDD-469F-4164-8A23-AB909001DF9E}"/>
               </a:ext>
             </a:extLst>
           </p:cNvPr>
@@ -9238,7 +9238,7 @@
           <p:cNvPr id="13" name="">
             <a:extLst xmlns:a="http://schemas.openxmlformats.org/drawingml/2006/main">
               <a:ext uri="{FF2B5EF4-FFF2-40B4-BE49-F238E27FC236}">
-                <a16:creationId xmlns:a16="http://schemas.microsoft.com/office/drawing/2014/main" id="{E0DA419F-6B90-4776-AA69-6835BFEB3E36}"/>
+                <a16:creationId xmlns:a16="http://schemas.microsoft.com/office/drawing/2014/main" id="{88896802-F750-44BA-83FB-59A76D69BAFE}"/>
               </a:ext>
             </a:extLst>
           </p:cNvPr>
@@ -9296,7 +9296,7 @@
           <p:cNvPr id="14" name="">
             <a:extLst xmlns:a="http://schemas.openxmlformats.org/drawingml/2006/main">
               <a:ext uri="{FF2B5EF4-FFF2-40B4-BE49-F238E27FC236}">
-                <a16:creationId xmlns:a16="http://schemas.microsoft.com/office/drawing/2014/main" id="{0501283C-263C-4387-8AA0-3E3039ED7D4E}"/>
+                <a16:creationId xmlns:a16="http://schemas.microsoft.com/office/drawing/2014/main" id="{50CE451A-96E1-4263-9CF4-8C7F88192520}"/>
               </a:ext>
             </a:extLst>
           </p:cNvPr>
@@ -9329,7 +9329,7 @@
           <p:cNvPr id="15" name="">
             <a:extLst xmlns:a="http://schemas.openxmlformats.org/drawingml/2006/main">
               <a:ext uri="{FF2B5EF4-FFF2-40B4-BE49-F238E27FC236}">
-                <a16:creationId xmlns:a16="http://schemas.microsoft.com/office/drawing/2014/main" id="{E6DF0499-2242-4815-9C41-B4C24C90BA6E}"/>
+                <a16:creationId xmlns:a16="http://schemas.microsoft.com/office/drawing/2014/main" id="{B87D5129-09E8-42D3-80C4-EA6FF10213AD}"/>
               </a:ext>
             </a:extLst>
           </p:cNvPr>
@@ -9387,7 +9387,7 @@
           <p:cNvPr id="16" name="">
             <a:extLst xmlns:a="http://schemas.openxmlformats.org/drawingml/2006/main">
               <a:ext uri="{FF2B5EF4-FFF2-40B4-BE49-F238E27FC236}">
-                <a16:creationId xmlns:a16="http://schemas.microsoft.com/office/drawing/2014/main" id="{4DF68350-5036-466C-B4E0-FEE37E001910}"/>
+                <a16:creationId xmlns:a16="http://schemas.microsoft.com/office/drawing/2014/main" id="{39433F51-910D-4B74-B9F8-2F5ADF884E1F}"/>
               </a:ext>
             </a:extLst>
           </p:cNvPr>
@@ -9445,7 +9445,7 @@
           <p:cNvPr id="17" name="">
             <a:extLst xmlns:a="http://schemas.openxmlformats.org/drawingml/2006/main">
               <a:ext uri="{FF2B5EF4-FFF2-40B4-BE49-F238E27FC236}">
-                <a16:creationId xmlns:a16="http://schemas.microsoft.com/office/drawing/2014/main" id="{3E6FDB85-8B91-4A8B-A507-49E8886AA545}"/>
+                <a16:creationId xmlns:a16="http://schemas.microsoft.com/office/drawing/2014/main" id="{DB32FBE8-F3D2-4FF9-8DC8-B687D84B69BA}"/>
               </a:ext>
             </a:extLst>
           </p:cNvPr>
@@ -9503,7 +9503,7 @@
           <p:cNvPr id="18" name="">
             <a:extLst xmlns:a="http://schemas.openxmlformats.org/drawingml/2006/main">
               <a:ext uri="{FF2B5EF4-FFF2-40B4-BE49-F238E27FC236}">
-                <a16:creationId xmlns:a16="http://schemas.microsoft.com/office/drawing/2014/main" id="{F4016DF2-DECD-4B54-9A76-24AC17E96275}"/>
+                <a16:creationId xmlns:a16="http://schemas.microsoft.com/office/drawing/2014/main" id="{47AE84FC-6B74-47BE-A3C5-06BA53D3FD4B}"/>
               </a:ext>
             </a:extLst>
           </p:cNvPr>
@@ -9559,7 +9559,7 @@
     </p:spTree>
     <p:extLst>
       <p:ext uri="{BB962C8B-B14F-4D97-AF65-F5344CB8AC3E}">
-        <p14:creationId xmlns:p14="http://schemas.microsoft.com/office/powerpoint/2010/main" val="1575667194"/>
+        <p14:creationId xmlns:p14="http://schemas.microsoft.com/office/powerpoint/2010/main" val="1309590320"/>
       </p:ext>
     </p:extLst>
   </p:cSld>
@@ -9590,7 +9590,7 @@
           <p:cNvPr id="17" name="">
             <a:extLst xmlns:a="http://schemas.openxmlformats.org/drawingml/2006/main">
               <a:ext uri="{FF2B5EF4-FFF2-40B4-BE49-F238E27FC236}">
-                <a16:creationId xmlns:a16="http://schemas.microsoft.com/office/drawing/2014/main" id="{DDD98AD5-F43E-41A0-813F-36656B939C5B}"/>
+                <a16:creationId xmlns:a16="http://schemas.microsoft.com/office/drawing/2014/main" id="{F0E1AA4F-1B2D-45C1-839F-17B7F7F8B6A7}"/>
               </a:ext>
             </a:extLst>
           </p:cNvPr>
@@ -9648,7 +9648,7 @@
           <p:cNvPr id="2" name="">
             <a:extLst xmlns:a="http://schemas.openxmlformats.org/drawingml/2006/main">
               <a:ext uri="{FF2B5EF4-FFF2-40B4-BE49-F238E27FC236}">
-                <a16:creationId xmlns:a16="http://schemas.microsoft.com/office/drawing/2014/main" id="{3B4273B2-0AD5-43C6-8FFA-97CE9B819E08}"/>
+                <a16:creationId xmlns:a16="http://schemas.microsoft.com/office/drawing/2014/main" id="{1DA1E65D-E20A-45D0-BF54-017EB9907D7B}"/>
               </a:ext>
             </a:extLst>
           </p:cNvPr>
@@ -9706,7 +9706,7 @@
           <p:cNvPr id="3" name="">
             <a:extLst xmlns:a="http://schemas.openxmlformats.org/drawingml/2006/main">
               <a:ext uri="{FF2B5EF4-FFF2-40B4-BE49-F238E27FC236}">
-                <a16:creationId xmlns:a16="http://schemas.microsoft.com/office/drawing/2014/main" id="{D4947092-2F19-4AF5-AA9D-7E3058E9CA39}"/>
+                <a16:creationId xmlns:a16="http://schemas.microsoft.com/office/drawing/2014/main" id="{DA188B12-50D4-471E-BA11-D177ACEAA7C5}"/>
               </a:ext>
             </a:extLst>
           </p:cNvPr>
@@ -9764,7 +9764,7 @@
           <p:cNvPr id="4" name="">
             <a:extLst xmlns:a="http://schemas.openxmlformats.org/drawingml/2006/main">
               <a:ext uri="{FF2B5EF4-FFF2-40B4-BE49-F238E27FC236}">
-                <a16:creationId xmlns:a16="http://schemas.microsoft.com/office/drawing/2014/main" id="{C2D114E1-9928-4CE4-9DEA-CBE87369206B}"/>
+                <a16:creationId xmlns:a16="http://schemas.microsoft.com/office/drawing/2014/main" id="{A991C9A5-85F6-4C3B-8C2F-D8B838597251}"/>
               </a:ext>
             </a:extLst>
           </p:cNvPr>
@@ -9822,7 +9822,7 @@
           <p:cNvPr id="5" name="">
             <a:extLst xmlns:a="http://schemas.openxmlformats.org/drawingml/2006/main">
               <a:ext uri="{FF2B5EF4-FFF2-40B4-BE49-F238E27FC236}">
-                <a16:creationId xmlns:a16="http://schemas.microsoft.com/office/drawing/2014/main" id="{662BD64D-2782-40AD-86F8-8B354E731C80}"/>
+                <a16:creationId xmlns:a16="http://schemas.microsoft.com/office/drawing/2014/main" id="{EE08F11C-B6C8-4372-9216-B6D11CC7E95B}"/>
               </a:ext>
             </a:extLst>
           </p:cNvPr>
@@ -9855,7 +9855,7 @@
           <p:cNvPr id="6" name="">
             <a:extLst xmlns:a="http://schemas.openxmlformats.org/drawingml/2006/main">
               <a:ext uri="{FF2B5EF4-FFF2-40B4-BE49-F238E27FC236}">
-                <a16:creationId xmlns:a16="http://schemas.microsoft.com/office/drawing/2014/main" id="{49D719C3-0C03-4CED-90BF-5B317E13135D}"/>
+                <a16:creationId xmlns:a16="http://schemas.microsoft.com/office/drawing/2014/main" id="{5844B8F1-A0A5-43EF-8DD3-0AA611E31BAC}"/>
               </a:ext>
             </a:extLst>
           </p:cNvPr>
@@ -9913,7 +9913,7 @@
           <p:cNvPr id="7" name="">
             <a:extLst xmlns:a="http://schemas.openxmlformats.org/drawingml/2006/main">
               <a:ext uri="{FF2B5EF4-FFF2-40B4-BE49-F238E27FC236}">
-                <a16:creationId xmlns:a16="http://schemas.microsoft.com/office/drawing/2014/main" id="{234C4A68-F85D-4455-9C52-82B6290323FA}"/>
+                <a16:creationId xmlns:a16="http://schemas.microsoft.com/office/drawing/2014/main" id="{5F173981-0B6A-4767-9D73-59FC8E7CE65E}"/>
               </a:ext>
             </a:extLst>
           </p:cNvPr>
@@ -9971,7 +9971,7 @@
           <p:cNvPr id="8" name="">
             <a:extLst xmlns:a="http://schemas.openxmlformats.org/drawingml/2006/main">
               <a:ext uri="{FF2B5EF4-FFF2-40B4-BE49-F238E27FC236}">
-                <a16:creationId xmlns:a16="http://schemas.microsoft.com/office/drawing/2014/main" id="{9F2A22DD-DB5C-4633-9A37-905252D14BBA}"/>
+                <a16:creationId xmlns:a16="http://schemas.microsoft.com/office/drawing/2014/main" id="{1C551A48-6846-4771-B9F5-E0CEC2C0C9F8}"/>
               </a:ext>
             </a:extLst>
           </p:cNvPr>
@@ -10004,7 +10004,7 @@
           <p:cNvPr id="9" name="">
             <a:extLst xmlns:a="http://schemas.openxmlformats.org/drawingml/2006/main">
               <a:ext uri="{FF2B5EF4-FFF2-40B4-BE49-F238E27FC236}">
-                <a16:creationId xmlns:a16="http://schemas.microsoft.com/office/drawing/2014/main" id="{7A886D7B-A7DD-4990-A2D7-ED71AE5B0F41}"/>
+                <a16:creationId xmlns:a16="http://schemas.microsoft.com/office/drawing/2014/main" id="{3B37F0DC-CC1C-49B5-A2AD-56A5080CA46D}"/>
               </a:ext>
             </a:extLst>
           </p:cNvPr>
@@ -10062,7 +10062,7 @@
           <p:cNvPr id="10" name="">
             <a:extLst xmlns:a="http://schemas.openxmlformats.org/drawingml/2006/main">
               <a:ext uri="{FF2B5EF4-FFF2-40B4-BE49-F238E27FC236}">
-                <a16:creationId xmlns:a16="http://schemas.microsoft.com/office/drawing/2014/main" id="{8761B6A7-51FF-4D43-98D9-A4FF5F003C15}"/>
+                <a16:creationId xmlns:a16="http://schemas.microsoft.com/office/drawing/2014/main" id="{18305705-D1B9-4893-B5D9-C7AE1A07DFB7}"/>
               </a:ext>
             </a:extLst>
           </p:cNvPr>
@@ -10120,7 +10120,7 @@
           <p:cNvPr id="11" name="">
             <a:extLst xmlns:a="http://schemas.openxmlformats.org/drawingml/2006/main">
               <a:ext uri="{FF2B5EF4-FFF2-40B4-BE49-F238E27FC236}">
-                <a16:creationId xmlns:a16="http://schemas.microsoft.com/office/drawing/2014/main" id="{0BCE5422-B0AD-4CF5-B2C5-AA7B11899E84}"/>
+                <a16:creationId xmlns:a16="http://schemas.microsoft.com/office/drawing/2014/main" id="{4E731994-0338-48A3-9300-FC4A33B535AE}"/>
               </a:ext>
             </a:extLst>
           </p:cNvPr>
@@ -10153,7 +10153,7 @@
           <p:cNvPr id="12" name="">
             <a:extLst xmlns:a="http://schemas.openxmlformats.org/drawingml/2006/main">
               <a:ext uri="{FF2B5EF4-FFF2-40B4-BE49-F238E27FC236}">
-                <a16:creationId xmlns:a16="http://schemas.microsoft.com/office/drawing/2014/main" id="{3B6E155F-2F21-4E57-9562-7A29FB3BE187}"/>
+                <a16:creationId xmlns:a16="http://schemas.microsoft.com/office/drawing/2014/main" id="{2DA62F32-9781-4F09-89A4-910E898FC348}"/>
               </a:ext>
             </a:extLst>
           </p:cNvPr>
@@ -10211,7 +10211,7 @@
           <p:cNvPr id="13" name="">
             <a:extLst xmlns:a="http://schemas.openxmlformats.org/drawingml/2006/main">
               <a:ext uri="{FF2B5EF4-FFF2-40B4-BE49-F238E27FC236}">
-                <a16:creationId xmlns:a16="http://schemas.microsoft.com/office/drawing/2014/main" id="{FB738C8F-127B-4AA4-861A-0B6E1A1443EF}"/>
+                <a16:creationId xmlns:a16="http://schemas.microsoft.com/office/drawing/2014/main" id="{6ABE65B8-A1FC-4024-9FEE-77523AA902B0}"/>
               </a:ext>
             </a:extLst>
           </p:cNvPr>
@@ -10269,7 +10269,7 @@
           <p:cNvPr id="14" name="">
             <a:extLst xmlns:a="http://schemas.openxmlformats.org/drawingml/2006/main">
               <a:ext uri="{FF2B5EF4-FFF2-40B4-BE49-F238E27FC236}">
-                <a16:creationId xmlns:a16="http://schemas.microsoft.com/office/drawing/2014/main" id="{4D0900DE-78D3-4C7A-8578-3678FDAC4F69}"/>
+                <a16:creationId xmlns:a16="http://schemas.microsoft.com/office/drawing/2014/main" id="{86C6B5A3-24E6-442C-8AD5-D8A75FDFCA3B}"/>
               </a:ext>
             </a:extLst>
           </p:cNvPr>
@@ -10302,7 +10302,7 @@
           <p:cNvPr id="15" name="">
             <a:extLst xmlns:a="http://schemas.openxmlformats.org/drawingml/2006/main">
               <a:ext uri="{FF2B5EF4-FFF2-40B4-BE49-F238E27FC236}">
-                <a16:creationId xmlns:a16="http://schemas.microsoft.com/office/drawing/2014/main" id="{40070EE5-87BD-4875-B3C7-89E1CB96ADD6}"/>
+                <a16:creationId xmlns:a16="http://schemas.microsoft.com/office/drawing/2014/main" id="{905D8404-0CCC-4F14-A43A-EAF43FEFB1FF}"/>
               </a:ext>
             </a:extLst>
           </p:cNvPr>
@@ -10360,7 +10360,7 @@
           <p:cNvPr id="16" name="">
             <a:extLst xmlns:a="http://schemas.openxmlformats.org/drawingml/2006/main">
               <a:ext uri="{FF2B5EF4-FFF2-40B4-BE49-F238E27FC236}">
-                <a16:creationId xmlns:a16="http://schemas.microsoft.com/office/drawing/2014/main" id="{E2D17D71-DAD5-48B5-8B42-ECA3D1920092}"/>
+                <a16:creationId xmlns:a16="http://schemas.microsoft.com/office/drawing/2014/main" id="{D92DED32-E013-4955-A15B-0E257C370950}"/>
               </a:ext>
             </a:extLst>
           </p:cNvPr>
@@ -10416,7 +10416,7 @@
     </p:spTree>
     <p:extLst>
       <p:ext uri="{BB962C8B-B14F-4D97-AF65-F5344CB8AC3E}">
-        <p14:creationId xmlns:p14="http://schemas.microsoft.com/office/powerpoint/2010/main" val="1315363487"/>
+        <p14:creationId xmlns:p14="http://schemas.microsoft.com/office/powerpoint/2010/main" val="1945204373"/>
       </p:ext>
     </p:extLst>
   </p:cSld>
@@ -10447,7 +10447,7 @@
           <p:cNvPr id="17" name="">
             <a:extLst xmlns:a="http://schemas.openxmlformats.org/drawingml/2006/main">
               <a:ext uri="{FF2B5EF4-FFF2-40B4-BE49-F238E27FC236}">
-                <a16:creationId xmlns:a16="http://schemas.microsoft.com/office/drawing/2014/main" id="{998AC090-D99E-4B5D-A1F1-C976CE3FC9A2}"/>
+                <a16:creationId xmlns:a16="http://schemas.microsoft.com/office/drawing/2014/main" id="{E6655832-404E-489E-A5CC-154D1B3A2FBA}"/>
               </a:ext>
             </a:extLst>
           </p:cNvPr>
@@ -10505,7 +10505,7 @@
           <p:cNvPr id="2" name="">
             <a:extLst xmlns:a="http://schemas.openxmlformats.org/drawingml/2006/main">
               <a:ext uri="{FF2B5EF4-FFF2-40B4-BE49-F238E27FC236}">
-                <a16:creationId xmlns:a16="http://schemas.microsoft.com/office/drawing/2014/main" id="{75794597-C2E3-403F-942C-136F59CCB9BF}"/>
+                <a16:creationId xmlns:a16="http://schemas.microsoft.com/office/drawing/2014/main" id="{04CF50AB-EF34-4167-BFE9-D9F5F980EE4E}"/>
               </a:ext>
             </a:extLst>
           </p:cNvPr>
@@ -10563,7 +10563,7 @@
           <p:cNvPr id="3" name="">
             <a:extLst xmlns:a="http://schemas.openxmlformats.org/drawingml/2006/main">
               <a:ext uri="{FF2B5EF4-FFF2-40B4-BE49-F238E27FC236}">
-                <a16:creationId xmlns:a16="http://schemas.microsoft.com/office/drawing/2014/main" id="{831758AE-2129-4C00-BCD8-976C68A780BB}"/>
+                <a16:creationId xmlns:a16="http://schemas.microsoft.com/office/drawing/2014/main" id="{DF22798D-90FA-47F6-A2B2-11D7D5CD872F}"/>
               </a:ext>
             </a:extLst>
           </p:cNvPr>
@@ -10621,7 +10621,7 @@
           <p:cNvPr id="4" name="">
             <a:extLst xmlns:a="http://schemas.openxmlformats.org/drawingml/2006/main">
               <a:ext uri="{FF2B5EF4-FFF2-40B4-BE49-F238E27FC236}">
-                <a16:creationId xmlns:a16="http://schemas.microsoft.com/office/drawing/2014/main" id="{239B898F-B9D1-4519-80D2-66C5F68EF46F}"/>
+                <a16:creationId xmlns:a16="http://schemas.microsoft.com/office/drawing/2014/main" id="{0378D3F2-04F3-4B7B-85E9-B00200A56B02}"/>
               </a:ext>
             </a:extLst>
           </p:cNvPr>
@@ -10679,7 +10679,7 @@
           <p:cNvPr id="5" name="">
             <a:extLst xmlns:a="http://schemas.openxmlformats.org/drawingml/2006/main">
               <a:ext uri="{FF2B5EF4-FFF2-40B4-BE49-F238E27FC236}">
-                <a16:creationId xmlns:a16="http://schemas.microsoft.com/office/drawing/2014/main" id="{D14D9F38-6F70-4A43-BD75-BFE932EA626F}"/>
+                <a16:creationId xmlns:a16="http://schemas.microsoft.com/office/drawing/2014/main" id="{2C861346-04A0-456C-A7C3-CDBEDB1E87F1}"/>
               </a:ext>
             </a:extLst>
           </p:cNvPr>
@@ -10712,7 +10712,7 @@
           <p:cNvPr id="6" name="">
             <a:extLst xmlns:a="http://schemas.openxmlformats.org/drawingml/2006/main">
               <a:ext uri="{FF2B5EF4-FFF2-40B4-BE49-F238E27FC236}">
-                <a16:creationId xmlns:a16="http://schemas.microsoft.com/office/drawing/2014/main" id="{21963743-0960-4B67-B313-0F0AD9D8523C}"/>
+                <a16:creationId xmlns:a16="http://schemas.microsoft.com/office/drawing/2014/main" id="{74F98A41-FE77-4020-BB19-5814262F10A5}"/>
               </a:ext>
             </a:extLst>
           </p:cNvPr>
@@ -10770,7 +10770,7 @@
           <p:cNvPr id="7" name="">
             <a:extLst xmlns:a="http://schemas.openxmlformats.org/drawingml/2006/main">
               <a:ext uri="{FF2B5EF4-FFF2-40B4-BE49-F238E27FC236}">
-                <a16:creationId xmlns:a16="http://schemas.microsoft.com/office/drawing/2014/main" id="{14FDEBB3-8966-4A6B-8768-3EFD1F92C0AF}"/>
+                <a16:creationId xmlns:a16="http://schemas.microsoft.com/office/drawing/2014/main" id="{85F25525-48A9-4D35-AFC8-C9492ABB2366}"/>
               </a:ext>
             </a:extLst>
           </p:cNvPr>
@@ -10828,7 +10828,7 @@
           <p:cNvPr id="8" name="">
             <a:extLst xmlns:a="http://schemas.openxmlformats.org/drawingml/2006/main">
               <a:ext uri="{FF2B5EF4-FFF2-40B4-BE49-F238E27FC236}">
-                <a16:creationId xmlns:a16="http://schemas.microsoft.com/office/drawing/2014/main" id="{51CDB371-1472-4A36-B276-36FEF841B047}"/>
+                <a16:creationId xmlns:a16="http://schemas.microsoft.com/office/drawing/2014/main" id="{1E23E838-98A5-4096-8603-3BC7331F424C}"/>
               </a:ext>
             </a:extLst>
           </p:cNvPr>
@@ -10859,7 +10859,7 @@
           <p:cNvPr id="9" name="">
             <a:extLst xmlns:a="http://schemas.openxmlformats.org/drawingml/2006/main">
               <a:ext uri="{FF2B5EF4-FFF2-40B4-BE49-F238E27FC236}">
-                <a16:creationId xmlns:a16="http://schemas.microsoft.com/office/drawing/2014/main" id="{FB402D49-94C8-4573-A7E1-03557F0DAFC9}"/>
+                <a16:creationId xmlns:a16="http://schemas.microsoft.com/office/drawing/2014/main" id="{55E457E0-3393-4082-A2FA-FBB609B38F58}"/>
               </a:ext>
             </a:extLst>
           </p:cNvPr>
@@ -10892,7 +10892,7 @@
           <p:cNvPr id="10" name="">
             <a:extLst xmlns:a="http://schemas.openxmlformats.org/drawingml/2006/main">
               <a:ext uri="{FF2B5EF4-FFF2-40B4-BE49-F238E27FC236}">
-                <a16:creationId xmlns:a16="http://schemas.microsoft.com/office/drawing/2014/main" id="{E601F799-8C56-402F-AB95-FC9C61A1ECFC}"/>
+                <a16:creationId xmlns:a16="http://schemas.microsoft.com/office/drawing/2014/main" id="{4D1308D1-4BC3-4475-B34D-D69FCE0865C1}"/>
               </a:ext>
             </a:extLst>
           </p:cNvPr>
@@ -10950,7 +10950,7 @@
           <p:cNvPr id="11" name="">
             <a:extLst xmlns:a="http://schemas.openxmlformats.org/drawingml/2006/main">
               <a:ext uri="{FF2B5EF4-FFF2-40B4-BE49-F238E27FC236}">
-                <a16:creationId xmlns:a16="http://schemas.microsoft.com/office/drawing/2014/main" id="{3D2A72F5-DC72-4878-9784-733CD341853A}"/>
+                <a16:creationId xmlns:a16="http://schemas.microsoft.com/office/drawing/2014/main" id="{82C76A16-2707-4917-834A-428AAC1DCBF9}"/>
               </a:ext>
             </a:extLst>
           </p:cNvPr>
@@ -11008,7 +11008,7 @@
           <p:cNvPr id="12" name="">
             <a:extLst xmlns:a="http://schemas.openxmlformats.org/drawingml/2006/main">
               <a:ext uri="{FF2B5EF4-FFF2-40B4-BE49-F238E27FC236}">
-                <a16:creationId xmlns:a16="http://schemas.microsoft.com/office/drawing/2014/main" id="{A9492262-09E4-4A85-B894-EE4913028BC5}"/>
+                <a16:creationId xmlns:a16="http://schemas.microsoft.com/office/drawing/2014/main" id="{C328F7D2-4B40-4D8D-B0B1-D30655427688}"/>
               </a:ext>
             </a:extLst>
           </p:cNvPr>
@@ -11039,7 +11039,7 @@
           <p:cNvPr id="13" name="">
             <a:extLst xmlns:a="http://schemas.openxmlformats.org/drawingml/2006/main">
               <a:ext uri="{FF2B5EF4-FFF2-40B4-BE49-F238E27FC236}">
-                <a16:creationId xmlns:a16="http://schemas.microsoft.com/office/drawing/2014/main" id="{5A060457-D4C3-40B9-8866-5379A7F27E0C}"/>
+                <a16:creationId xmlns:a16="http://schemas.microsoft.com/office/drawing/2014/main" id="{4887CB1B-30A8-43E4-8B73-55F66710BD6B}"/>
               </a:ext>
             </a:extLst>
           </p:cNvPr>
@@ -11072,7 +11072,7 @@
           <p:cNvPr id="14" name="">
             <a:extLst xmlns:a="http://schemas.openxmlformats.org/drawingml/2006/main">
               <a:ext uri="{FF2B5EF4-FFF2-40B4-BE49-F238E27FC236}">
-                <a16:creationId xmlns:a16="http://schemas.microsoft.com/office/drawing/2014/main" id="{DB32399F-95A7-4C38-808A-E2B80892D47B}"/>
+                <a16:creationId xmlns:a16="http://schemas.microsoft.com/office/drawing/2014/main" id="{D20D6875-81B3-4739-958E-0DC6623E0BA6}"/>
               </a:ext>
             </a:extLst>
           </p:cNvPr>
@@ -11130,7 +11130,7 @@
           <p:cNvPr id="15" name="">
             <a:extLst xmlns:a="http://schemas.openxmlformats.org/drawingml/2006/main">
               <a:ext uri="{FF2B5EF4-FFF2-40B4-BE49-F238E27FC236}">
-                <a16:creationId xmlns:a16="http://schemas.microsoft.com/office/drawing/2014/main" id="{98FD0D6E-4E9C-49C7-B28D-996F05E43667}"/>
+                <a16:creationId xmlns:a16="http://schemas.microsoft.com/office/drawing/2014/main" id="{886523FE-8F46-405D-AE01-B2529AFC3846}"/>
               </a:ext>
             </a:extLst>
           </p:cNvPr>
@@ -11188,7 +11188,7 @@
           <p:cNvPr id="16" name="">
             <a:extLst xmlns:a="http://schemas.openxmlformats.org/drawingml/2006/main">
               <a:ext uri="{FF2B5EF4-FFF2-40B4-BE49-F238E27FC236}">
-                <a16:creationId xmlns:a16="http://schemas.microsoft.com/office/drawing/2014/main" id="{2EBF0D2F-4786-4B42-BF0D-21153BFAFEC1}"/>
+                <a16:creationId xmlns:a16="http://schemas.microsoft.com/office/drawing/2014/main" id="{81D460F8-3FF7-4423-A4CD-B2E9C638E56D}"/>
               </a:ext>
             </a:extLst>
           </p:cNvPr>
@@ -11217,7 +11217,7 @@
     </p:spTree>
     <p:extLst>
       <p:ext uri="{BB962C8B-B14F-4D97-AF65-F5344CB8AC3E}">
-        <p14:creationId xmlns:p14="http://schemas.microsoft.com/office/powerpoint/2010/main" val="450593042"/>
+        <p14:creationId xmlns:p14="http://schemas.microsoft.com/office/powerpoint/2010/main" val="718153774"/>
       </p:ext>
     </p:extLst>
   </p:cSld>

</xml_diff>